<commit_message>
Set all slides to BIZ UDPGothic and record the font rule
- Pin the typeface on every run, table cell, chart text and bullet; set the
  template theme fonts to BIZ UDPGothic
- Replace glyphs the font lacks (Greek letters, subscripts, emoji) with words
  or drawn shapes; render app mockups in the same font
- Add fonts/setup_font.sh to install the font for PDF and image checks
- Fix layout issues that appeared with the real font metrics
- Add CLAUDE.md with the standing font rule

Co-Authored-By: Claude Sonnet 5.5 <noreply@anthropic.com>
Claude-Session: https://claude.ai/code/session_01EfAf68qAaSyRQmx5B725mW
</commit_message>
<xml_diff>
--- a/research-materials/slides/01_進捗報告①_20261016_OshiFit_v2設計.pptx
+++ b/research-materials/slides/01_進捗報告①_20261016_OshiFit_v2設計.pptx
@@ -153,8 +153,11 @@
                 <a:solidFill>
                   <a:srgbClr val="0B3C6E"/>
                 </a:solidFill>
-              </a:rPr>
-              <a:t>予備調査215名のパス係数（β）</a:t>
+                <a:latin typeface="BIZ UDPゴシック"/>
+                <a:ea typeface="BIZ UDPゴシック"/>
+                <a:cs typeface="BIZ UDPゴシック"/>
+              </a:rPr>
+              <a:t>予備調査215名のパス係数</a:t>
             </a:r>
           </a:p>
         </c:rich>
@@ -176,7 +179,7 @@
               <c:strCache>
                 <c:ptCount val="1"/>
                 <c:pt idx="0">
-                  <c:v>標準化係数 β</c:v>
+                  <c:v>標準化係数</c:v>
                 </c:pt>
               </c:strCache>
             </c:strRef>
@@ -272,6 +275,9 @@
                   <a:solidFill>
                     <a:srgbClr val="24303F"/>
                   </a:solidFill>
+                  <a:latin typeface="BIZ UDPゴシック"/>
+                  <a:ea typeface="BIZ UDPゴシック"/>
+                  <a:cs typeface="BIZ UDPゴシック"/>
                 </a:defRPr>
               </a:pPr>
             </a:p>
@@ -315,6 +321,9 @@
                 <a:solidFill>
                   <a:srgbClr val="24303F"/>
                 </a:solidFill>
+                <a:latin typeface="BIZ UDPゴシック"/>
+                <a:ea typeface="BIZ UDPゴシック"/>
+                <a:cs typeface="BIZ UDPゴシック"/>
               </a:defRPr>
             </a:pPr>
           </a:p>
@@ -361,6 +370,9 @@
                 <a:solidFill>
                   <a:srgbClr val="5A6676"/>
                 </a:solidFill>
+                <a:latin typeface="BIZ UDPゴシック"/>
+                <a:ea typeface="BIZ UDPゴシック"/>
+                <a:cs typeface="BIZ UDPゴシック"/>
               </a:defRPr>
             </a:pPr>
           </a:p>
@@ -381,9 +393,16 @@
           <a:solidFill>
             <a:srgbClr val="5A6676"/>
           </a:solidFill>
+          <a:latin typeface="BIZ UDPゴシック"/>
+          <a:ea typeface="BIZ UDPゴシック"/>
+          <a:cs typeface="BIZ UDPゴシック"/>
         </a:defRPr>
       </a:pPr>
-      <a:endParaRPr lang="en-US"/>
+      <a:endParaRPr lang="en-US">
+        <a:latin typeface="BIZ UDPゴシック"/>
+        <a:ea typeface="BIZ UDPゴシック"/>
+        <a:cs typeface="BIZ UDPゴシック"/>
+      </a:endParaRPr>
     </a:p>
   </c:txPr>
   <c:externalData r:id="rId1">
@@ -407,6 +426,9 @@
                 <a:solidFill>
                   <a:srgbClr val="0B3C6E"/>
                 </a:solidFill>
+                <a:latin typeface="BIZ UDPゴシック"/>
+                <a:ea typeface="BIZ UDPゴシック"/>
+                <a:cs typeface="BIZ UDPゴシック"/>
               </a:rPr>
               <a:t>記録日数と80%予測区間の幅（±）</a:t>
             </a:r>
@@ -470,6 +492,9 @@
                       <a:solidFill>
                         <a:srgbClr val="E07A10"/>
                       </a:solidFill>
+                      <a:latin typeface="BIZ UDPゴシック"/>
+                      <a:ea typeface="BIZ UDPゴシック"/>
+                      <a:cs typeface="BIZ UDPゴシック"/>
                     </a:defRPr>
                   </a:pPr>
                 </a:p>
@@ -600,6 +625,9 @@
                       <a:solidFill>
                         <a:srgbClr val="12A38A"/>
                       </a:solidFill>
+                      <a:latin typeface="BIZ UDPゴシック"/>
+                      <a:ea typeface="BIZ UDPゴシック"/>
+                      <a:cs typeface="BIZ UDPゴシック"/>
                     </a:defRPr>
                   </a:pPr>
                 </a:p>
@@ -712,6 +740,9 @@
                 <a:solidFill>
                   <a:srgbClr val="24303F"/>
                 </a:solidFill>
+                <a:latin typeface="BIZ UDPゴシック"/>
+                <a:ea typeface="BIZ UDPゴシック"/>
+                <a:cs typeface="BIZ UDPゴシック"/>
               </a:defRPr>
             </a:pPr>
           </a:p>
@@ -758,6 +789,9 @@
                 <a:solidFill>
                   <a:srgbClr val="5A6676"/>
                 </a:solidFill>
+                <a:latin typeface="BIZ UDPゴシック"/>
+                <a:ea typeface="BIZ UDPゴシック"/>
+                <a:cs typeface="BIZ UDPゴシック"/>
               </a:defRPr>
             </a:pPr>
           </a:p>
@@ -776,7 +810,11 @@
         <a:lstStyle/>
         <a:p>
           <a:pPr>
-            <a:defRPr sz="1100"/>
+            <a:defRPr sz="1100">
+              <a:latin typeface="BIZ UDPゴシック"/>
+              <a:ea typeface="BIZ UDPゴシック"/>
+              <a:cs typeface="BIZ UDPゴシック"/>
+            </a:defRPr>
           </a:pPr>
         </a:p>
       </c:txPr>
@@ -794,9 +832,16 @@
           <a:solidFill>
             <a:srgbClr val="5A6676"/>
           </a:solidFill>
+          <a:latin typeface="BIZ UDPゴシック"/>
+          <a:ea typeface="BIZ UDPゴシック"/>
+          <a:cs typeface="BIZ UDPゴシック"/>
         </a:defRPr>
       </a:pPr>
-      <a:endParaRPr lang="en-US"/>
+      <a:endParaRPr lang="en-US">
+        <a:latin typeface="BIZ UDPゴシック"/>
+        <a:ea typeface="BIZ UDPゴシック"/>
+        <a:cs typeface="BIZ UDPゴシック"/>
+      </a:endParaRPr>
     </a:p>
   </c:txPr>
   <c:externalData r:id="rId1">
@@ -4773,7 +4818,7 @@
         <p:spPr>
           <a:xfrm>
             <a:off x="0" y="855796"/>
-            <a:ext cx="5115503" cy="300082"/>
+            <a:ext cx="6200000" cy="300082"/>
           </a:xfrm>
           <a:prstGeom prst="rect">
             <a:avLst/>
@@ -5226,6 +5271,9 @@
                 <a:solidFill>
                   <a:srgbClr val="24303F"/>
                 </a:solidFill>
+                <a:latin typeface="BIZ UDPゴシック"/>
+                <a:ea typeface="BIZ UDPゴシック"/>
+                <a:cs typeface="BIZ UDPゴシック"/>
               </a:rPr>
               <a:t>進捗報告 2026/10/16</a:t>
             </a:r>
@@ -5260,6 +5308,9 @@
                 <a:solidFill>
                   <a:srgbClr val="24303F"/>
                 </a:solidFill>
+                <a:latin typeface="BIZ UDPゴシック"/>
+                <a:ea typeface="BIZ UDPゴシック"/>
+                <a:cs typeface="BIZ UDPゴシック"/>
               </a:rPr>
               <a:t>今井元</a:t>
             </a:r>
@@ -5301,6 +5352,9 @@
                 <a:solidFill>
                   <a:srgbClr val="24303F"/>
                 </a:solidFill>
+                <a:latin typeface="BIZ UDPゴシック"/>
+                <a:ea typeface="BIZ UDPゴシック"/>
+                <a:cs typeface="BIZ UDPゴシック"/>
               </a:rPr>
               <a:t>メディアインタラクション研究室　進捗報告</a:t>
             </a:r>
@@ -5340,6 +5394,9 @@
                 <a:solidFill>
                   <a:srgbClr val="24303F"/>
                 </a:solidFill>
+                <a:latin typeface="BIZ UDPゴシック"/>
+                <a:ea typeface="BIZ UDPゴシック"/>
+                <a:cs typeface="BIZ UDPゴシック"/>
               </a:rPr>
               <a:t>大阪工業大学</a:t>
             </a:r>
@@ -5356,6 +5413,9 @@
                 <a:solidFill>
                   <a:srgbClr val="24303F"/>
                 </a:solidFill>
+                <a:latin typeface="BIZ UDPゴシック"/>
+                <a:ea typeface="BIZ UDPゴシック"/>
+                <a:cs typeface="BIZ UDPゴシック"/>
               </a:rPr>
               <a:t>メディアインタラクション研究室</a:t>
             </a:r>
@@ -5398,6 +5458,9 @@
                 <a:solidFill>
                   <a:srgbClr val="FFFFFF"/>
                 </a:solidFill>
+                <a:latin typeface="BIZ UDPゴシック"/>
+                <a:ea typeface="BIZ UDPゴシック"/>
+                <a:cs typeface="BIZ UDPゴシック"/>
               </a:rPr>
               <a:t>OshiFit v2</a:t>
             </a:r>
@@ -5417,6 +5480,9 @@
                 <a:solidFill>
                   <a:srgbClr val="FFFFFF"/>
                 </a:solidFill>
+                <a:latin typeface="BIZ UDPゴシック"/>
+                <a:ea typeface="BIZ UDPゴシック"/>
+                <a:cs typeface="BIZ UDPゴシック"/>
               </a:rPr>
               <a:t>「ゆらぎアバター」でシステムを再設計</a:t>
             </a:r>
@@ -5436,6 +5502,9 @@
                 <a:solidFill>
                   <a:srgbClr val="FFFFFF"/>
                 </a:solidFill>
+                <a:latin typeface="BIZ UDPゴシック"/>
+                <a:ea typeface="BIZ UDPゴシック"/>
+                <a:cs typeface="BIZ UDPゴシック"/>
               </a:rPr>
               <a:t>倫理審査の申請 ／ 予測モデル v1.0 の固定</a:t>
             </a:r>
@@ -5512,6 +5581,9 @@
                 <a:solidFill>
                   <a:srgbClr val="24303F"/>
                 </a:solidFill>
+                <a:latin typeface="BIZ UDPゴシック"/>
+                <a:ea typeface="BIZ UDPゴシック"/>
+                <a:cs typeface="BIZ UDPゴシック"/>
               </a:rPr>
               <a:t>新しい仕組み③ リバランス提案エンジン</a:t>
             </a:r>
@@ -5530,9 +5602,14 @@
         </p:nvSpPr>
         <p:spPr/>
         <p:txBody>
-          <a:bodyPr/>
-          <a:p>
-            <a:r>
+          <a:bodyPr lIns="27432" rIns="0" wrap="none"/>
+          <a:p>
+            <a:r>
+              <a:rPr sz="900">
+                <a:latin typeface="BIZ UDPゴシック"/>
+                <a:ea typeface="BIZ UDPゴシック"/>
+                <a:cs typeface="BIZ UDPゴシック"/>
+              </a:rPr>
               <a:t>2026/10/16</a:t>
             </a:r>
           </a:p>
@@ -5553,7 +5630,11 @@
           <a:bodyPr/>
           <a:p>
             <a:fld id="{B6F15528-21DE-4FAA-801E-634DDDAF4B2B}" type="slidenum">
-              <a:rPr lang="en-US"/>
+              <a:rPr lang="en-US">
+                <a:latin typeface="BIZ UDPゴシック"/>
+                <a:ea typeface="BIZ UDPゴシック"/>
+                <a:cs typeface="BIZ UDPゴシック"/>
+              </a:rPr>
               <a:t>10</a:t>
             </a:fld>
           </a:p>
@@ -5592,6 +5673,9 @@
                 <a:solidFill>
                   <a:srgbClr val="0B3C6E"/>
                 </a:solidFill>
+                <a:latin typeface="BIZ UDPゴシック"/>
+                <a:ea typeface="BIZ UDPゴシック"/>
+                <a:cs typeface="BIZ UDPゴシック"/>
               </a:rPr>
               <a:t>「減らす」のではなく「組み替える」— 本人の希望を守ったまま、疲れの少ない配分を探す</a:t>
             </a:r>
@@ -5675,6 +5759,9 @@
                 <a:solidFill>
                   <a:srgbClr val="0B3C6E"/>
                 </a:solidFill>
+                <a:latin typeface="BIZ UDPゴシック"/>
+                <a:ea typeface="BIZ UDPゴシック"/>
+                <a:cs typeface="BIZ UDPゴシック"/>
               </a:rPr>
               <a:t>1. 候補をつくる</a:t>
             </a:r>
@@ -5714,6 +5801,9 @@
                 <a:solidFill>
                   <a:srgbClr val="24303F"/>
                 </a:solidFill>
+                <a:latin typeface="BIZ UDPゴシック"/>
+                <a:ea typeface="BIZ UDPゴシック"/>
+                <a:cs typeface="BIZ UDPゴシック"/>
               </a:rPr>
               <a:t>7つの活動を</a:t>
             </a:r>
@@ -5730,6 +5820,9 @@
                 <a:solidFill>
                   <a:srgbClr val="24303F"/>
                 </a:solidFill>
+                <a:latin typeface="BIZ UDPゴシック"/>
+                <a:ea typeface="BIZ UDPゴシック"/>
+                <a:cs typeface="BIZ UDPゴシック"/>
               </a:rPr>
               <a:t>−1／0／+1 段階変える</a:t>
             </a:r>
@@ -5746,6 +5839,9 @@
                 <a:solidFill>
                   <a:srgbClr val="24303F"/>
                 </a:solidFill>
+                <a:latin typeface="BIZ UDPゴシック"/>
+                <a:ea typeface="BIZ UDPゴシック"/>
+                <a:cs typeface="BIZ UDPゴシック"/>
               </a:rPr>
               <a:t>（同時に2つまで）</a:t>
             </a:r>
@@ -5829,6 +5925,9 @@
                 <a:solidFill>
                   <a:srgbClr val="0B3C6E"/>
                 </a:solidFill>
+                <a:latin typeface="BIZ UDPゴシック"/>
+                <a:ea typeface="BIZ UDPゴシック"/>
+                <a:cs typeface="BIZ UDPゴシック"/>
               </a:rPr>
               <a:t>2. 予測する</a:t>
             </a:r>
@@ -5868,6 +5967,9 @@
                 <a:solidFill>
                   <a:srgbClr val="24303F"/>
                 </a:solidFill>
+                <a:latin typeface="BIZ UDPゴシック"/>
+                <a:ea typeface="BIZ UDPゴシック"/>
+                <a:cs typeface="BIZ UDPゴシック"/>
               </a:rPr>
               <a:t>ツインで充実と</a:t>
             </a:r>
@@ -5884,6 +5986,9 @@
                 <a:solidFill>
                   <a:srgbClr val="24303F"/>
                 </a:solidFill>
+                <a:latin typeface="BIZ UDPゴシック"/>
+                <a:ea typeface="BIZ UDPゴシック"/>
+                <a:cs typeface="BIZ UDPゴシック"/>
               </a:rPr>
               <a:t>推し疲れを予測</a:t>
             </a:r>
@@ -5967,6 +6072,9 @@
                 <a:solidFill>
                   <a:srgbClr val="0B3C6E"/>
                 </a:solidFill>
+                <a:latin typeface="BIZ UDPゴシック"/>
+                <a:ea typeface="BIZ UDPゴシック"/>
+                <a:cs typeface="BIZ UDPゴシック"/>
               </a:rPr>
               <a:t>3. 絞り込む</a:t>
             </a:r>
@@ -6006,6 +6114,9 @@
                 <a:solidFill>
                   <a:srgbClr val="24303F"/>
                 </a:solidFill>
+                <a:latin typeface="BIZ UDPゴシック"/>
+                <a:ea typeface="BIZ UDPゴシック"/>
+                <a:cs typeface="BIZ UDPゴシック"/>
               </a:rPr>
               <a:t>「増やしたい」活動は</a:t>
             </a:r>
@@ -6022,6 +6133,9 @@
                 <a:solidFill>
                   <a:srgbClr val="24303F"/>
                 </a:solidFill>
+                <a:latin typeface="BIZ UDPゴシック"/>
+                <a:ea typeface="BIZ UDPゴシック"/>
+                <a:cs typeface="BIZ UDPゴシック"/>
               </a:rPr>
               <a:t>減らさない</a:t>
             </a:r>
@@ -6105,6 +6219,9 @@
                 <a:solidFill>
                   <a:srgbClr val="FFFFFF"/>
                 </a:solidFill>
+                <a:latin typeface="BIZ UDPゴシック"/>
+                <a:ea typeface="BIZ UDPゴシック"/>
+                <a:cs typeface="BIZ UDPゴシック"/>
               </a:rPr>
               <a:t>4. 3案を出す</a:t>
             </a:r>
@@ -6144,6 +6261,9 @@
                 <a:solidFill>
                   <a:srgbClr val="FFFFFF"/>
                 </a:solidFill>
+                <a:latin typeface="BIZ UDPゴシック"/>
+                <a:ea typeface="BIZ UDPゴシック"/>
+                <a:cs typeface="BIZ UDPゴシック"/>
               </a:rPr>
               <a:t>楽しさキープ／バランス</a:t>
             </a:r>
@@ -6160,6 +6280,9 @@
                 <a:solidFill>
                   <a:srgbClr val="FFFFFF"/>
                 </a:solidFill>
+                <a:latin typeface="BIZ UDPゴシック"/>
+                <a:ea typeface="BIZ UDPゴシック"/>
+                <a:cs typeface="BIZ UDPゴシック"/>
               </a:rPr>
               <a:t>／回復重視</a:t>
             </a:r>
@@ -6199,6 +6322,9 @@
                 <a:solidFill>
                   <a:srgbClr val="E8457C"/>
                 </a:solidFill>
+                <a:latin typeface="BIZ UDPゴシック"/>
+                <a:ea typeface="BIZ UDPゴシック"/>
+                <a:cs typeface="BIZ UDPゴシック"/>
               </a:rPr>
               <a:t>例：「ライブは増やしたい／SNSは減らしたい」大学生（睡眠と比較の疲れが高い）</a:t>
             </a:r>
@@ -6248,6 +6374,9 @@
                           <a:solidFill>
                             <a:srgbClr val="FFFFFF"/>
                           </a:solidFill>
+                          <a:latin typeface="BIZ UDPゴシック"/>
+                          <a:ea typeface="BIZ UDPゴシック"/>
+                          <a:cs typeface="BIZ UDPゴシック"/>
                         </a:rPr>
                         <a:t>案</a:t>
                       </a:r>
@@ -6297,6 +6426,9 @@
                           <a:solidFill>
                             <a:srgbClr val="FFFFFF"/>
                           </a:solidFill>
+                          <a:latin typeface="BIZ UDPゴシック"/>
+                          <a:ea typeface="BIZ UDPゴシック"/>
+                          <a:cs typeface="BIZ UDPゴシック"/>
                         </a:rPr>
                         <a:t>内容</a:t>
                       </a:r>
@@ -6346,6 +6478,9 @@
                           <a:solidFill>
                             <a:srgbClr val="FFFFFF"/>
                           </a:solidFill>
+                          <a:latin typeface="BIZ UDPゴシック"/>
+                          <a:ea typeface="BIZ UDPゴシック"/>
+                          <a:cs typeface="BIZ UDPゴシック"/>
                         </a:rPr>
                         <a:t>充実</a:t>
                       </a:r>
@@ -6395,6 +6530,9 @@
                           <a:solidFill>
                             <a:srgbClr val="FFFFFF"/>
                           </a:solidFill>
+                          <a:latin typeface="BIZ UDPゴシック"/>
+                          <a:ea typeface="BIZ UDPゴシック"/>
+                          <a:cs typeface="BIZ UDPゴシック"/>
                         </a:rPr>
                         <a:t>推し疲れ</a:t>
                       </a:r>
@@ -6446,6 +6584,9 @@
                           <a:solidFill>
                             <a:srgbClr val="24303F"/>
                           </a:solidFill>
+                          <a:latin typeface="BIZ UDPゴシック"/>
+                          <a:ea typeface="BIZ UDPゴシック"/>
+                          <a:cs typeface="BIZ UDPゴシック"/>
                         </a:rPr>
                         <a:t>① 楽しさキープ型</a:t>
                       </a:r>
@@ -6495,6 +6636,9 @@
                           <a:solidFill>
                             <a:srgbClr val="24303F"/>
                           </a:solidFill>
+                          <a:latin typeface="BIZ UDPゴシック"/>
+                          <a:ea typeface="BIZ UDPゴシック"/>
+                          <a:cs typeface="BIZ UDPゴシック"/>
                         </a:rPr>
                         <a:t>夜のSNSを1時間短くし、配信は週末にまとめて見る</a:t>
                       </a:r>
@@ -6544,6 +6688,9 @@
                           <a:solidFill>
                             <a:srgbClr val="24303F"/>
                           </a:solidFill>
+                          <a:latin typeface="BIZ UDPゴシック"/>
+                          <a:ea typeface="BIZ UDPゴシック"/>
+                          <a:cs typeface="BIZ UDPゴシック"/>
                         </a:rPr>
                         <a:t>±0</a:t>
                       </a:r>
@@ -6593,6 +6740,9 @@
                           <a:solidFill>
                             <a:srgbClr val="24303F"/>
                           </a:solidFill>
+                          <a:latin typeface="BIZ UDPゴシック"/>
+                          <a:ea typeface="BIZ UDPゴシック"/>
+                          <a:cs typeface="BIZ UDPゴシック"/>
                         </a:rPr>
                         <a:t>−0.4</a:t>
                       </a:r>
@@ -6644,6 +6794,9 @@
                           <a:solidFill>
                             <a:srgbClr val="24303F"/>
                           </a:solidFill>
+                          <a:latin typeface="BIZ UDPゴシック"/>
+                          <a:ea typeface="BIZ UDPゴシック"/>
+                          <a:cs typeface="BIZ UDPゴシック"/>
                         </a:rPr>
                         <a:t>② バランス型</a:t>
                       </a:r>
@@ -6693,6 +6846,9 @@
                           <a:solidFill>
                             <a:srgbClr val="24303F"/>
                           </a:solidFill>
+                          <a:latin typeface="BIZ UDPゴシック"/>
+                          <a:ea typeface="BIZ UDPゴシック"/>
+                          <a:cs typeface="BIZ UDPゴシック"/>
                         </a:rPr>
                         <a:t>グッズは月1回の「まとめ買い日」に。浮いた分をライブ遠征へ</a:t>
                       </a:r>
@@ -6742,6 +6898,9 @@
                           <a:solidFill>
                             <a:srgbClr val="24303F"/>
                           </a:solidFill>
+                          <a:latin typeface="BIZ UDPゴシック"/>
+                          <a:ea typeface="BIZ UDPゴシック"/>
+                          <a:cs typeface="BIZ UDPゴシック"/>
                         </a:rPr>
                         <a:t>+0.2</a:t>
                       </a:r>
@@ -6791,6 +6950,9 @@
                           <a:solidFill>
                             <a:srgbClr val="24303F"/>
                           </a:solidFill>
+                          <a:latin typeface="BIZ UDPゴシック"/>
+                          <a:ea typeface="BIZ UDPゴシック"/>
+                          <a:cs typeface="BIZ UDPゴシック"/>
                         </a:rPr>
                         <a:t>−0.2</a:t>
                       </a:r>
@@ -6842,6 +7004,9 @@
                           <a:solidFill>
                             <a:srgbClr val="24303F"/>
                           </a:solidFill>
+                          <a:latin typeface="BIZ UDPゴシック"/>
+                          <a:ea typeface="BIZ UDPゴシック"/>
+                          <a:cs typeface="BIZ UDPゴシック"/>
                         </a:rPr>
                         <a:t>③ 回復重視型</a:t>
                       </a:r>
@@ -6891,6 +7056,9 @@
                           <a:solidFill>
                             <a:srgbClr val="24303F"/>
                           </a:solidFill>
+                          <a:latin typeface="BIZ UDPゴシック"/>
+                          <a:ea typeface="BIZ UDPゴシック"/>
+                          <a:cs typeface="BIZ UDPゴシック"/>
                         </a:rPr>
                         <a:t>24時以降はSNSオフ、睡眠を1時間ふやす</a:t>
                       </a:r>
@@ -6940,6 +7108,9 @@
                           <a:solidFill>
                             <a:srgbClr val="24303F"/>
                           </a:solidFill>
+                          <a:latin typeface="BIZ UDPゴシック"/>
+                          <a:ea typeface="BIZ UDPゴシック"/>
+                          <a:cs typeface="BIZ UDPゴシック"/>
                         </a:rPr>
                         <a:t>−0.2</a:t>
                       </a:r>
@@ -6989,6 +7160,9 @@
                           <a:solidFill>
                             <a:srgbClr val="24303F"/>
                           </a:solidFill>
+                          <a:latin typeface="BIZ UDPゴシック"/>
+                          <a:ea typeface="BIZ UDPゴシック"/>
+                          <a:cs typeface="BIZ UDPゴシック"/>
                         </a:rPr>
                         <a:t>−0.7</a:t>
                       </a:r>
@@ -7058,6 +7232,9 @@
                 <a:solidFill>
                   <a:srgbClr val="5A6676"/>
                 </a:solidFill>
+                <a:latin typeface="BIZ UDPゴシック"/>
+                <a:ea typeface="BIZ UDPゴシック"/>
+                <a:cs typeface="BIZ UDPゴシック"/>
               </a:rPr>
               <a:t>3案はどれも「充実を大きく下げずに疲れを下げる」パレート最適な組み合わせから選ぶ。選ばない自由も残す</a:t>
             </a:r>
@@ -7121,6 +7298,9 @@
                 <a:solidFill>
                   <a:srgbClr val="E8457C"/>
                 </a:solidFill>
+                <a:latin typeface="BIZ UDPゴシック"/>
+                <a:ea typeface="BIZ UDPゴシック"/>
+                <a:cs typeface="BIZ UDPゴシック"/>
               </a:rPr>
               <a:t>※ 予測差は例示の値</a:t>
             </a:r>
@@ -7173,6 +7353,9 @@
                 <a:solidFill>
                   <a:srgbClr val="24303F"/>
                 </a:solidFill>
+                <a:latin typeface="BIZ UDPゴシック"/>
+                <a:ea typeface="BIZ UDPゴシック"/>
+                <a:cs typeface="BIZ UDPゴシック"/>
               </a:rPr>
               <a:t>新しい仕組み④ 疲れの中身キュー</a:t>
             </a:r>
@@ -7191,9 +7374,14 @@
         </p:nvSpPr>
         <p:spPr/>
         <p:txBody>
-          <a:bodyPr/>
-          <a:p>
-            <a:r>
+          <a:bodyPr lIns="27432" rIns="0" wrap="none"/>
+          <a:p>
+            <a:r>
+              <a:rPr sz="900">
+                <a:latin typeface="BIZ UDPゴシック"/>
+                <a:ea typeface="BIZ UDPゴシック"/>
+                <a:cs typeface="BIZ UDPゴシック"/>
+              </a:rPr>
               <a:t>2026/10/16</a:t>
             </a:r>
           </a:p>
@@ -7214,7 +7402,11 @@
           <a:bodyPr/>
           <a:p>
             <a:fld id="{B6F15528-21DE-4FAA-801E-634DDDAF4B2B}" type="slidenum">
-              <a:rPr lang="en-US"/>
+              <a:rPr lang="en-US">
+                <a:latin typeface="BIZ UDPゴシック"/>
+                <a:ea typeface="BIZ UDPゴシック"/>
+                <a:cs typeface="BIZ UDPゴシック"/>
+              </a:rPr>
               <a:t>11</a:t>
             </a:fld>
           </a:p>
@@ -7327,6 +7519,9 @@
                 <a:solidFill>
                   <a:srgbClr val="FFFFFF"/>
                 </a:solidFill>
+                <a:latin typeface="BIZ UDPゴシック"/>
+                <a:ea typeface="BIZ UDPゴシック"/>
+                <a:cs typeface="BIZ UDPゴシック"/>
               </a:rPr>
               <a:t>睡眠</a:t>
             </a:r>
@@ -7390,6 +7585,9 @@
                 <a:solidFill>
                   <a:srgbClr val="5A6676"/>
                 </a:solidFill>
+                <a:latin typeface="BIZ UDPゴシック"/>
+                <a:ea typeface="BIZ UDPゴシック"/>
+                <a:cs typeface="BIZ UDPゴシック"/>
               </a:rPr>
               <a:t>アバターの手がかり</a:t>
             </a:r>
@@ -7429,6 +7627,9 @@
                 <a:solidFill>
                   <a:srgbClr val="0B3C6E"/>
                 </a:solidFill>
+                <a:latin typeface="BIZ UDPゴシック"/>
+                <a:ea typeface="BIZ UDPゴシック"/>
+                <a:cs typeface="BIZ UDPゴシック"/>
               </a:rPr>
               <a:t>くま・Zz</a:t>
             </a:r>
@@ -7468,6 +7669,9 @@
                 <a:solidFill>
                   <a:srgbClr val="5A6676"/>
                 </a:solidFill>
+                <a:latin typeface="BIZ UDPゴシック"/>
+                <a:ea typeface="BIZ UDPゴシック"/>
+                <a:cs typeface="BIZ UDPゴシック"/>
               </a:rPr>
               <a:t>提案の例</a:t>
             </a:r>
@@ -7507,6 +7711,9 @@
                 <a:solidFill>
                   <a:srgbClr val="12A38A"/>
                 </a:solidFill>
+                <a:latin typeface="BIZ UDPゴシック"/>
+                <a:ea typeface="BIZ UDPゴシック"/>
+                <a:cs typeface="BIZ UDPゴシック"/>
               </a:rPr>
               <a:t>配信は翌朝の</a:t>
             </a:r>
@@ -7523,6 +7730,9 @@
                 <a:solidFill>
                   <a:srgbClr val="12A38A"/>
                 </a:solidFill>
+                <a:latin typeface="BIZ UDPゴシック"/>
+                <a:ea typeface="BIZ UDPゴシック"/>
+                <a:cs typeface="BIZ UDPゴシック"/>
               </a:rPr>
               <a:t>アーカイブで見る</a:t>
             </a:r>
@@ -7636,6 +7846,9 @@
                 <a:solidFill>
                   <a:srgbClr val="FFFFFF"/>
                 </a:solidFill>
+                <a:latin typeface="BIZ UDPゴシック"/>
+                <a:ea typeface="BIZ UDPゴシック"/>
+                <a:cs typeface="BIZ UDPゴシック"/>
               </a:rPr>
               <a:t>出費</a:t>
             </a:r>
@@ -7699,6 +7912,9 @@
                 <a:solidFill>
                   <a:srgbClr val="5A6676"/>
                 </a:solidFill>
+                <a:latin typeface="BIZ UDPゴシック"/>
+                <a:ea typeface="BIZ UDPゴシック"/>
+                <a:cs typeface="BIZ UDPゴシック"/>
               </a:rPr>
               <a:t>アバターの手がかり</a:t>
             </a:r>
@@ -7738,6 +7954,9 @@
                 <a:solidFill>
                   <a:srgbClr val="0B3C6E"/>
                 </a:solidFill>
+                <a:latin typeface="BIZ UDPゴシック"/>
+                <a:ea typeface="BIZ UDPゴシック"/>
+                <a:cs typeface="BIZ UDPゴシック"/>
               </a:rPr>
               <a:t>軽くなった財布</a:t>
             </a:r>
@@ -7777,6 +7996,9 @@
                 <a:solidFill>
                   <a:srgbClr val="5A6676"/>
                 </a:solidFill>
+                <a:latin typeface="BIZ UDPゴシック"/>
+                <a:ea typeface="BIZ UDPゴシック"/>
+                <a:cs typeface="BIZ UDPゴシック"/>
               </a:rPr>
               <a:t>提案の例</a:t>
             </a:r>
@@ -7816,6 +8038,9 @@
                 <a:solidFill>
                   <a:srgbClr val="12A38A"/>
                 </a:solidFill>
+                <a:latin typeface="BIZ UDPゴシック"/>
+                <a:ea typeface="BIZ UDPゴシック"/>
+                <a:cs typeface="BIZ UDPゴシック"/>
               </a:rPr>
               <a:t>月1回の</a:t>
             </a:r>
@@ -7832,6 +8057,9 @@
                 <a:solidFill>
                   <a:srgbClr val="12A38A"/>
                 </a:solidFill>
+                <a:latin typeface="BIZ UDPゴシック"/>
+                <a:ea typeface="BIZ UDPゴシック"/>
+                <a:cs typeface="BIZ UDPゴシック"/>
               </a:rPr>
               <a:t>「まとめ買い日」</a:t>
             </a:r>
@@ -7945,6 +8173,9 @@
                 <a:solidFill>
                   <a:srgbClr val="FFFFFF"/>
                 </a:solidFill>
+                <a:latin typeface="BIZ UDPゴシック"/>
+                <a:ea typeface="BIZ UDPゴシック"/>
+                <a:cs typeface="BIZ UDPゴシック"/>
               </a:rPr>
               <a:t>義務感</a:t>
             </a:r>
@@ -8008,6 +8239,9 @@
                 <a:solidFill>
                   <a:srgbClr val="5A6676"/>
                 </a:solidFill>
+                <a:latin typeface="BIZ UDPゴシック"/>
+                <a:ea typeface="BIZ UDPゴシック"/>
+                <a:cs typeface="BIZ UDPゴシック"/>
               </a:rPr>
               <a:t>アバターの手がかり</a:t>
             </a:r>
@@ -8047,6 +8281,9 @@
                 <a:solidFill>
                   <a:srgbClr val="0B3C6E"/>
                 </a:solidFill>
+                <a:latin typeface="BIZ UDPゴシック"/>
+                <a:ea typeface="BIZ UDPゴシック"/>
+                <a:cs typeface="BIZ UDPゴシック"/>
               </a:rPr>
               <a:t>重いリュック</a:t>
             </a:r>
@@ -8086,6 +8323,9 @@
                 <a:solidFill>
                   <a:srgbClr val="5A6676"/>
                 </a:solidFill>
+                <a:latin typeface="BIZ UDPゴシック"/>
+                <a:ea typeface="BIZ UDPゴシック"/>
+                <a:cs typeface="BIZ UDPゴシック"/>
               </a:rPr>
               <a:t>提案の例</a:t>
             </a:r>
@@ -8125,6 +8365,9 @@
                 <a:solidFill>
                   <a:srgbClr val="12A38A"/>
                 </a:solidFill>
+                <a:latin typeface="BIZ UDPゴシック"/>
+                <a:ea typeface="BIZ UDPゴシック"/>
+                <a:cs typeface="BIZ UDPゴシック"/>
               </a:rPr>
               <a:t>「全部追う」を</a:t>
             </a:r>
@@ -8141,6 +8384,9 @@
                 <a:solidFill>
                   <a:srgbClr val="12A38A"/>
                 </a:solidFill>
+                <a:latin typeface="BIZ UDPゴシック"/>
+                <a:ea typeface="BIZ UDPゴシック"/>
+                <a:cs typeface="BIZ UDPゴシック"/>
               </a:rPr>
               <a:t>やめる棚卸し</a:t>
             </a:r>
@@ -8254,6 +8500,9 @@
                 <a:solidFill>
                   <a:srgbClr val="FFFFFF"/>
                 </a:solidFill>
+                <a:latin typeface="BIZ UDPゴシック"/>
+                <a:ea typeface="BIZ UDPゴシック"/>
+                <a:cs typeface="BIZ UDPゴシック"/>
               </a:rPr>
               <a:t>比較</a:t>
             </a:r>
@@ -8317,6 +8566,9 @@
                 <a:solidFill>
                   <a:srgbClr val="5A6676"/>
                 </a:solidFill>
+                <a:latin typeface="BIZ UDPゴシック"/>
+                <a:ea typeface="BIZ UDPゴシック"/>
+                <a:cs typeface="BIZ UDPゴシック"/>
               </a:rPr>
               <a:t>アバターの手がかり</a:t>
             </a:r>
@@ -8356,6 +8608,9 @@
                 <a:solidFill>
                   <a:srgbClr val="0B3C6E"/>
                 </a:solidFill>
+                <a:latin typeface="BIZ UDPゴシック"/>
+                <a:ea typeface="BIZ UDPゴシック"/>
+                <a:cs typeface="BIZ UDPゴシック"/>
               </a:rPr>
               <a:t>スマホの光</a:t>
             </a:r>
@@ -8395,6 +8650,9 @@
                 <a:solidFill>
                   <a:srgbClr val="5A6676"/>
                 </a:solidFill>
+                <a:latin typeface="BIZ UDPゴシック"/>
+                <a:ea typeface="BIZ UDPゴシック"/>
+                <a:cs typeface="BIZ UDPゴシック"/>
               </a:rPr>
               <a:t>提案の例</a:t>
             </a:r>
@@ -8434,6 +8692,9 @@
                 <a:solidFill>
                   <a:srgbClr val="12A38A"/>
                 </a:solidFill>
+                <a:latin typeface="BIZ UDPゴシック"/>
+                <a:ea typeface="BIZ UDPゴシック"/>
+                <a:cs typeface="BIZ UDPゴシック"/>
               </a:rPr>
               <a:t>ミュートワードを</a:t>
             </a:r>
@@ -8450,6 +8711,9 @@
                 <a:solidFill>
                   <a:srgbClr val="12A38A"/>
                 </a:solidFill>
+                <a:latin typeface="BIZ UDPゴシック"/>
+                <a:ea typeface="BIZ UDPゴシック"/>
+                <a:cs typeface="BIZ UDPゴシック"/>
               </a:rPr>
               <a:t>設定する</a:t>
             </a:r>
@@ -8511,6 +8775,9 @@
                 <a:solidFill>
                   <a:srgbClr val="0B3C6E"/>
                 </a:solidFill>
+                <a:latin typeface="BIZ UDPゴシック"/>
+                <a:ea typeface="BIZ UDPゴシック"/>
+                <a:cs typeface="BIZ UDPゴシック"/>
               </a:rPr>
               <a:t>表現は予測の区分（3段階）にだけ連動させ、大げさな疲れの表現はしない（倫理審査の方針どおり）</a:t>
             </a:r>
@@ -8563,6 +8830,9 @@
                 <a:solidFill>
                   <a:srgbClr val="24303F"/>
                 </a:solidFill>
+                <a:latin typeface="BIZ UDPゴシック"/>
+                <a:ea typeface="BIZ UDPゴシック"/>
+                <a:cs typeface="BIZ UDPゴシック"/>
               </a:rPr>
               <a:t>3群の画面のちがい（公平な比較のために）</a:t>
             </a:r>
@@ -8581,9 +8851,14 @@
         </p:nvSpPr>
         <p:spPr/>
         <p:txBody>
-          <a:bodyPr/>
-          <a:p>
-            <a:r>
+          <a:bodyPr lIns="27432" rIns="0" wrap="none"/>
+          <a:p>
+            <a:r>
+              <a:rPr sz="900">
+                <a:latin typeface="BIZ UDPゴシック"/>
+                <a:ea typeface="BIZ UDPゴシック"/>
+                <a:cs typeface="BIZ UDPゴシック"/>
+              </a:rPr>
               <a:t>2026/10/16</a:t>
             </a:r>
           </a:p>
@@ -8604,7 +8879,11 @@
           <a:bodyPr/>
           <a:p>
             <a:fld id="{B6F15528-21DE-4FAA-801E-634DDDAF4B2B}" type="slidenum">
-              <a:rPr lang="en-US"/>
+              <a:rPr lang="en-US">
+                <a:latin typeface="BIZ UDPゴシック"/>
+                <a:ea typeface="BIZ UDPゴシック"/>
+                <a:cs typeface="BIZ UDPゴシック"/>
+              </a:rPr>
               <a:t>12</a:t>
             </a:fld>
           </a:p>
@@ -8653,6 +8932,9 @@
                           <a:solidFill>
                             <a:srgbClr val="FFFFFF"/>
                           </a:solidFill>
+                          <a:latin typeface="BIZ UDPゴシック"/>
+                          <a:ea typeface="BIZ UDPゴシック"/>
+                          <a:cs typeface="BIZ UDPゴシック"/>
                         </a:rPr>
                         <a:t>機能</a:t>
                       </a:r>
@@ -8702,6 +8984,9 @@
                           <a:solidFill>
                             <a:srgbClr val="FFFFFF"/>
                           </a:solidFill>
+                          <a:latin typeface="BIZ UDPゴシック"/>
+                          <a:ea typeface="BIZ UDPゴシック"/>
+                          <a:cs typeface="BIZ UDPゴシック"/>
                         </a:rPr>
                         <a:t>群A 記録のみ</a:t>
                       </a:r>
@@ -8751,6 +9036,9 @@
                           <a:solidFill>
                             <a:srgbClr val="FFFFFF"/>
                           </a:solidFill>
+                          <a:latin typeface="BIZ UDPゴシック"/>
+                          <a:ea typeface="BIZ UDPゴシック"/>
+                          <a:cs typeface="BIZ UDPゴシック"/>
                         </a:rPr>
                         <a:t>群B 提案（文章）</a:t>
                       </a:r>
@@ -8800,6 +9088,9 @@
                           <a:solidFill>
                             <a:srgbClr val="FFFFFF"/>
                           </a:solidFill>
+                          <a:latin typeface="BIZ UDPゴシック"/>
+                          <a:ea typeface="BIZ UDPゴシック"/>
+                          <a:cs typeface="BIZ UDPゴシック"/>
                         </a:rPr>
                         <a:t>群C 提案＋予測アバター</a:t>
                       </a:r>
@@ -8851,6 +9142,9 @@
                           <a:solidFill>
                             <a:srgbClr val="24303F"/>
                           </a:solidFill>
+                          <a:latin typeface="BIZ UDPゴシック"/>
+                          <a:ea typeface="BIZ UDPゴシック"/>
+                          <a:cs typeface="BIZ UDPゴシック"/>
                         </a:rPr>
                         <a:t>毎日の記録・週1回の振り返り</a:t>
                       </a:r>
@@ -8900,6 +9194,9 @@
                           <a:solidFill>
                             <a:srgbClr val="24303F"/>
                           </a:solidFill>
+                          <a:latin typeface="BIZ UDPゴシック"/>
+                          <a:ea typeface="BIZ UDPゴシック"/>
+                          <a:cs typeface="BIZ UDPゴシック"/>
                         </a:rPr>
                         <a:t>○</a:t>
                       </a:r>
@@ -8949,6 +9246,9 @@
                           <a:solidFill>
                             <a:srgbClr val="24303F"/>
                           </a:solidFill>
+                          <a:latin typeface="BIZ UDPゴシック"/>
+                          <a:ea typeface="BIZ UDPゴシック"/>
+                          <a:cs typeface="BIZ UDPゴシック"/>
                         </a:rPr>
                         <a:t>○</a:t>
                       </a:r>
@@ -8998,6 +9298,9 @@
                           <a:solidFill>
                             <a:srgbClr val="24303F"/>
                           </a:solidFill>
+                          <a:latin typeface="BIZ UDPゴシック"/>
+                          <a:ea typeface="BIZ UDPゴシック"/>
+                          <a:cs typeface="BIZ UDPゴシック"/>
                         </a:rPr>
                         <a:t>○</a:t>
                       </a:r>
@@ -9049,6 +9352,9 @@
                           <a:solidFill>
                             <a:srgbClr val="24303F"/>
                           </a:solidFill>
+                          <a:latin typeface="BIZ UDPゴシック"/>
+                          <a:ea typeface="BIZ UDPゴシック"/>
+                          <a:cs typeface="BIZ UDPゴシック"/>
                         </a:rPr>
                         <a:t>アバター作成</a:t>
                       </a:r>
@@ -9098,6 +9404,9 @@
                           <a:solidFill>
                             <a:srgbClr val="24303F"/>
                           </a:solidFill>
+                          <a:latin typeface="BIZ UDPゴシック"/>
+                          <a:ea typeface="BIZ UDPゴシック"/>
+                          <a:cs typeface="BIZ UDPゴシック"/>
                         </a:rPr>
                         <a:t>○（プロフィールのみ）</a:t>
                       </a:r>
@@ -9147,6 +9456,9 @@
                           <a:solidFill>
                             <a:srgbClr val="24303F"/>
                           </a:solidFill>
+                          <a:latin typeface="BIZ UDPゴシック"/>
+                          <a:ea typeface="BIZ UDPゴシック"/>
+                          <a:cs typeface="BIZ UDPゴシック"/>
                         </a:rPr>
                         <a:t>○（プロフィールのみ）</a:t>
                       </a:r>
@@ -9196,6 +9508,9 @@
                           <a:solidFill>
                             <a:srgbClr val="24303F"/>
                           </a:solidFill>
+                          <a:latin typeface="BIZ UDPゴシック"/>
+                          <a:ea typeface="BIZ UDPゴシック"/>
+                          <a:cs typeface="BIZ UDPゴシック"/>
                         </a:rPr>
                         <a:t>○</a:t>
                       </a:r>
@@ -9247,6 +9562,9 @@
                           <a:solidFill>
                             <a:srgbClr val="24303F"/>
                           </a:solidFill>
+                          <a:latin typeface="BIZ UDPゴシック"/>
+                          <a:ea typeface="BIZ UDPゴシック"/>
+                          <a:cs typeface="BIZ UDPゴシック"/>
                         </a:rPr>
                         <a:t>週1回の提案（3案から選ぶ）</a:t>
                       </a:r>
@@ -9296,6 +9614,9 @@
                           <a:solidFill>
                             <a:srgbClr val="24303F"/>
                           </a:solidFill>
+                          <a:latin typeface="BIZ UDPゴシック"/>
+                          <a:ea typeface="BIZ UDPゴシック"/>
+                          <a:cs typeface="BIZ UDPゴシック"/>
                         </a:rPr>
                         <a:t>—</a:t>
                       </a:r>
@@ -9345,6 +9666,9 @@
                           <a:solidFill>
                             <a:srgbClr val="24303F"/>
                           </a:solidFill>
+                          <a:latin typeface="BIZ UDPゴシック"/>
+                          <a:ea typeface="BIZ UDPゴシック"/>
+                          <a:cs typeface="BIZ UDPゴシック"/>
                         </a:rPr>
                         <a:t>○（予測値なし）</a:t>
                       </a:r>
@@ -9394,6 +9718,9 @@
                           <a:solidFill>
                             <a:srgbClr val="24303F"/>
                           </a:solidFill>
+                          <a:latin typeface="BIZ UDPゴシック"/>
+                          <a:ea typeface="BIZ UDPゴシック"/>
+                          <a:cs typeface="BIZ UDPゴシック"/>
                         </a:rPr>
                         <a:t>○（同じ3案）</a:t>
                       </a:r>
@@ -9445,6 +9772,9 @@
                           <a:solidFill>
                             <a:srgbClr val="24303F"/>
                           </a:solidFill>
+                          <a:latin typeface="BIZ UDPゴシック"/>
+                          <a:ea typeface="BIZ UDPゴシック"/>
+                          <a:cs typeface="BIZ UDPゴシック"/>
                         </a:rPr>
                         <a:t>みらいミラー（予測値＋ゆらぎアバター）</a:t>
                       </a:r>
@@ -9494,6 +9824,9 @@
                           <a:solidFill>
                             <a:srgbClr val="24303F"/>
                           </a:solidFill>
+                          <a:latin typeface="BIZ UDPゴシック"/>
+                          <a:ea typeface="BIZ UDPゴシック"/>
+                          <a:cs typeface="BIZ UDPゴシック"/>
                         </a:rPr>
                         <a:t>—</a:t>
                       </a:r>
@@ -9543,6 +9876,9 @@
                           <a:solidFill>
                             <a:srgbClr val="24303F"/>
                           </a:solidFill>
+                          <a:latin typeface="BIZ UDPゴシック"/>
+                          <a:ea typeface="BIZ UDPゴシック"/>
+                          <a:cs typeface="BIZ UDPゴシック"/>
                         </a:rPr>
                         <a:t>—</a:t>
                       </a:r>
@@ -9592,6 +9928,9 @@
                           <a:solidFill>
                             <a:srgbClr val="24303F"/>
                           </a:solidFill>
+                          <a:latin typeface="BIZ UDPゴシック"/>
+                          <a:ea typeface="BIZ UDPゴシック"/>
+                          <a:cs typeface="BIZ UDPゴシック"/>
                         </a:rPr>
                         <a:t>○</a:t>
                       </a:r>
@@ -9643,6 +9982,9 @@
                           <a:solidFill>
                             <a:srgbClr val="24303F"/>
                           </a:solidFill>
+                          <a:latin typeface="BIZ UDPゴシック"/>
+                          <a:ea typeface="BIZ UDPゴシック"/>
+                          <a:cs typeface="BIZ UDPゴシック"/>
                         </a:rPr>
                         <a:t>疲れの中身キュー</a:t>
                       </a:r>
@@ -9692,6 +10034,9 @@
                           <a:solidFill>
                             <a:srgbClr val="24303F"/>
                           </a:solidFill>
+                          <a:latin typeface="BIZ UDPゴシック"/>
+                          <a:ea typeface="BIZ UDPゴシック"/>
+                          <a:cs typeface="BIZ UDPゴシック"/>
                         </a:rPr>
                         <a:t>—</a:t>
                       </a:r>
@@ -9741,6 +10086,9 @@
                           <a:solidFill>
                             <a:srgbClr val="24303F"/>
                           </a:solidFill>
+                          <a:latin typeface="BIZ UDPゴシック"/>
+                          <a:ea typeface="BIZ UDPゴシック"/>
+                          <a:cs typeface="BIZ UDPゴシック"/>
                         </a:rPr>
                         <a:t>—</a:t>
                       </a:r>
@@ -9790,6 +10138,9 @@
                           <a:solidFill>
                             <a:srgbClr val="24303F"/>
                           </a:solidFill>
+                          <a:latin typeface="BIZ UDPゴシック"/>
+                          <a:ea typeface="BIZ UDPゴシック"/>
+                          <a:cs typeface="BIZ UDPゴシック"/>
                         </a:rPr>
                         <a:t>○</a:t>
                       </a:r>
@@ -9841,6 +10192,9 @@
                           <a:solidFill>
                             <a:srgbClr val="24303F"/>
                           </a:solidFill>
+                          <a:latin typeface="BIZ UDPゴシック"/>
+                          <a:ea typeface="BIZ UDPゴシック"/>
+                          <a:cs typeface="BIZ UDPゴシック"/>
                         </a:rPr>
                         <a:t>予測の答え合わせ</a:t>
                       </a:r>
@@ -9890,6 +10244,9 @@
                           <a:solidFill>
                             <a:srgbClr val="24303F"/>
                           </a:solidFill>
+                          <a:latin typeface="BIZ UDPゴシック"/>
+                          <a:ea typeface="BIZ UDPゴシック"/>
+                          <a:cs typeface="BIZ UDPゴシック"/>
                         </a:rPr>
                         <a:t>—</a:t>
                       </a:r>
@@ -9939,6 +10296,9 @@
                           <a:solidFill>
                             <a:srgbClr val="24303F"/>
                           </a:solidFill>
+                          <a:latin typeface="BIZ UDPゴシック"/>
+                          <a:ea typeface="BIZ UDPゴシック"/>
+                          <a:cs typeface="BIZ UDPゴシック"/>
                         </a:rPr>
                         <a:t>—</a:t>
                       </a:r>
@@ -9988,6 +10348,9 @@
                           <a:solidFill>
                             <a:srgbClr val="24303F"/>
                           </a:solidFill>
+                          <a:latin typeface="BIZ UDPゴシック"/>
+                          <a:ea typeface="BIZ UDPゴシック"/>
+                          <a:cs typeface="BIZ UDPゴシック"/>
                         </a:rPr>
                         <a:t>○</a:t>
                       </a:r>
@@ -10167,6 +10530,9 @@
                 <a:solidFill>
                   <a:srgbClr val="0B3C6E"/>
                 </a:solidFill>
+                <a:latin typeface="BIZ UDPゴシック"/>
+                <a:ea typeface="BIZ UDPゴシック"/>
+                <a:cs typeface="BIZ UDPゴシック"/>
               </a:rPr>
               <a:t>群Bと群Cの差は「予測の見せ方」だけにそろえる</a:t>
             </a:r>
@@ -10183,6 +10549,9 @@
                 <a:solidFill>
                   <a:srgbClr val="24303F"/>
                 </a:solidFill>
+                <a:latin typeface="BIZ UDPゴシック"/>
+                <a:ea typeface="BIZ UDPゴシック"/>
+                <a:cs typeface="BIZ UDPゴシック"/>
               </a:rPr>
               <a:t>提案の中身・数・頻度は同一。群Bの提案カードには予測値を出さない → RQ2（アバターの効果）を純粋に比較できる</a:t>
             </a:r>
@@ -10235,6 +10604,9 @@
                 <a:solidFill>
                   <a:srgbClr val="24303F"/>
                 </a:solidFill>
+                <a:latin typeface="BIZ UDPゴシック"/>
+                <a:ea typeface="BIZ UDPゴシック"/>
+                <a:cs typeface="BIZ UDPゴシック"/>
               </a:rPr>
               <a:t>次回（10/30）までの予定と相談事項</a:t>
             </a:r>
@@ -10253,9 +10625,14 @@
         </p:nvSpPr>
         <p:spPr/>
         <p:txBody>
-          <a:bodyPr/>
-          <a:p>
-            <a:r>
+          <a:bodyPr lIns="27432" rIns="0" wrap="none"/>
+          <a:p>
+            <a:r>
+              <a:rPr sz="900">
+                <a:latin typeface="BIZ UDPゴシック"/>
+                <a:ea typeface="BIZ UDPゴシック"/>
+                <a:cs typeface="BIZ UDPゴシック"/>
+              </a:rPr>
               <a:t>2026/10/16</a:t>
             </a:r>
           </a:p>
@@ -10276,7 +10653,11 @@
           <a:bodyPr/>
           <a:p>
             <a:fld id="{B6F15528-21DE-4FAA-801E-634DDDAF4B2B}" type="slidenum">
-              <a:rPr lang="en-US"/>
+              <a:rPr lang="en-US">
+                <a:latin typeface="BIZ UDPゴシック"/>
+                <a:ea typeface="BIZ UDPゴシック"/>
+                <a:cs typeface="BIZ UDPゴシック"/>
+              </a:rPr>
               <a:t>13</a:t>
             </a:fld>
           </a:p>
@@ -10315,6 +10696,9 @@
                 <a:solidFill>
                   <a:srgbClr val="0B3C6E"/>
                 </a:solidFill>
+                <a:latin typeface="BIZ UDPゴシック"/>
+                <a:ea typeface="BIZ UDPゴシック"/>
+                <a:cs typeface="BIZ UDPゴシック"/>
               </a:rPr>
               <a:t>やること</a:t>
             </a:r>
@@ -10376,6 +10760,9 @@
                 <a:solidFill>
                   <a:srgbClr val="FFFFFF"/>
                 </a:solidFill>
+                <a:latin typeface="BIZ UDPゴシック"/>
+                <a:ea typeface="BIZ UDPゴシック"/>
+                <a:cs typeface="BIZ UDPゴシック"/>
               </a:rPr>
               <a:t>10/19</a:t>
             </a:r>
@@ -10415,6 +10802,9 @@
                 <a:solidFill>
                   <a:srgbClr val="24303F"/>
                 </a:solidFill>
+                <a:latin typeface="BIZ UDPゴシック"/>
+                <a:ea typeface="BIZ UDPゴシック"/>
+                <a:cs typeface="BIZ UDPゴシック"/>
               </a:rPr>
               <a:t>アバター生成（端末内の顔特徴点 → パーツ合成）</a:t>
             </a:r>
@@ -10476,6 +10866,9 @@
                 <a:solidFill>
                   <a:srgbClr val="FFFFFF"/>
                 </a:solidFill>
+                <a:latin typeface="BIZ UDPゴシック"/>
+                <a:ea typeface="BIZ UDPゴシック"/>
+                <a:cs typeface="BIZ UDPゴシック"/>
               </a:rPr>
               <a:t>10/22</a:t>
             </a:r>
@@ -10515,6 +10908,9 @@
                 <a:solidFill>
                   <a:srgbClr val="24303F"/>
                 </a:solidFill>
+                <a:latin typeface="BIZ UDPゴシック"/>
+                <a:ea typeface="BIZ UDPゴシック"/>
+                <a:cs typeface="BIZ UDPゴシック"/>
               </a:rPr>
               <a:t>ゆらぎアバターとみらいミラー画面</a:t>
             </a:r>
@@ -10576,6 +10972,9 @@
                 <a:solidFill>
                   <a:srgbClr val="FFFFFF"/>
                 </a:solidFill>
+                <a:latin typeface="BIZ UDPゴシック"/>
+                <a:ea typeface="BIZ UDPゴシック"/>
+                <a:cs typeface="BIZ UDPゴシック"/>
               </a:rPr>
               <a:t>10/24–26</a:t>
             </a:r>
@@ -10615,6 +11014,9 @@
                 <a:solidFill>
                   <a:srgbClr val="24303F"/>
                 </a:solidFill>
+                <a:latin typeface="BIZ UDPゴシック"/>
+                <a:ea typeface="BIZ UDPゴシック"/>
+                <a:cs typeface="BIZ UDPゴシック"/>
               </a:rPr>
               <a:t>研究室内での操作確認（5〜8名）</a:t>
             </a:r>
@@ -10676,6 +11078,9 @@
                 <a:solidFill>
                   <a:srgbClr val="FFFFFF"/>
                 </a:solidFill>
+                <a:latin typeface="BIZ UDPゴシック"/>
+                <a:ea typeface="BIZ UDPゴシック"/>
+                <a:cs typeface="BIZ UDPゴシック"/>
               </a:rPr>
               <a:t>10/29</a:t>
             </a:r>
@@ -10715,6 +11120,9 @@
                 <a:solidFill>
                   <a:srgbClr val="24303F"/>
                 </a:solidFill>
+                <a:latin typeface="BIZ UDPゴシック"/>
+                <a:ea typeface="BIZ UDPゴシック"/>
+                <a:cs typeface="BIZ UDPゴシック"/>
               </a:rPr>
               <a:t>CHIIR 2027 Short Paper を投稿</a:t>
             </a:r>
@@ -10776,6 +11184,9 @@
                 <a:solidFill>
                   <a:srgbClr val="FFFFFF"/>
                 </a:solidFill>
+                <a:latin typeface="BIZ UDPゴシック"/>
+                <a:ea typeface="BIZ UDPゴシック"/>
+                <a:cs typeface="BIZ UDPゴシック"/>
               </a:rPr>
               <a:t>10/30</a:t>
             </a:r>
@@ -10815,8 +11226,11 @@
                 <a:solidFill>
                   <a:srgbClr val="24303F"/>
                 </a:solidFill>
-              </a:rPr>
-              <a:t>β版を凍結（本実験用）</a:t>
+                <a:latin typeface="BIZ UDPゴシック"/>
+                <a:ea typeface="BIZ UDPゴシック"/>
+                <a:cs typeface="BIZ UDPゴシック"/>
+              </a:rPr>
+              <a:t>ベータ版を凍結（本実験用）</a:t>
             </a:r>
           </a:p>
         </p:txBody>
@@ -10964,6 +11378,9 @@
                 <a:solidFill>
                   <a:srgbClr val="E8457C"/>
                 </a:solidFill>
+                <a:latin typeface="BIZ UDPゴシック"/>
+                <a:ea typeface="BIZ UDPゴシック"/>
+                <a:cs typeface="BIZ UDPゴシック"/>
               </a:rPr>
               <a:t>相談したいこと</a:t>
             </a:r>
@@ -11003,6 +11420,9 @@
                 <a:solidFill>
                   <a:srgbClr val="0B3C6E"/>
                 </a:solidFill>
+                <a:latin typeface="BIZ UDPゴシック"/>
+                <a:ea typeface="BIZ UDPゴシック"/>
+                <a:cs typeface="BIZ UDPゴシック"/>
               </a:rPr>
               <a:t>承認が10/30より遅れた場合の開始日</a:t>
             </a:r>
@@ -11019,6 +11439,9 @@
                 <a:solidFill>
                   <a:srgbClr val="24303F"/>
                 </a:solidFill>
+                <a:latin typeface="BIZ UDPゴシック"/>
+                <a:ea typeface="BIZ UDPゴシック"/>
+                <a:cs typeface="BIZ UDPゴシック"/>
               </a:rPr>
               <a:t>11/9開始なら終了は12/20。解析期間が約1週間減る</a:t>
             </a:r>
@@ -11035,6 +11458,9 @@
                 <a:solidFill>
                   <a:srgbClr val="0B3C6E"/>
                 </a:solidFill>
+                <a:latin typeface="BIZ UDPゴシック"/>
+                <a:ea typeface="BIZ UDPゴシック"/>
+                <a:cs typeface="BIZ UDPゴシック"/>
               </a:rPr>
               <a:t>募集経路と謝礼</a:t>
             </a:r>
@@ -11051,6 +11477,9 @@
                 <a:solidFill>
                   <a:srgbClr val="24303F"/>
                 </a:solidFill>
+                <a:latin typeface="BIZ UDPゴシック"/>
+                <a:ea typeface="BIZ UDPゴシック"/>
+                <a:cs typeface="BIZ UDPゴシック"/>
               </a:rPr>
               <a:t>学内メーリングリスト、X、推し活コミュニティ。謝礼の額と支払い方法</a:t>
             </a:r>
@@ -11067,6 +11496,9 @@
                 <a:solidFill>
                   <a:srgbClr val="0B3C6E"/>
                 </a:solidFill>
+                <a:latin typeface="BIZ UDPゴシック"/>
+                <a:ea typeface="BIZ UDPゴシック"/>
+                <a:cs typeface="BIZ UDPゴシック"/>
               </a:rPr>
               <a:t>CHIIR の投稿区分</a:t>
             </a:r>
@@ -11083,6 +11515,9 @@
                 <a:solidFill>
                   <a:srgbClr val="24303F"/>
                 </a:solidFill>
+                <a:latin typeface="BIZ UDPゴシック"/>
+                <a:ea typeface="BIZ UDPゴシック"/>
+                <a:cs typeface="BIZ UDPゴシック"/>
               </a:rPr>
               <a:t>Short Paper（4ページ）とDemoのどちらにするか</a:t>
             </a:r>
@@ -11232,6 +11667,9 @@
                 <a:solidFill>
                   <a:srgbClr val="0B3C6E"/>
                 </a:solidFill>
+                <a:latin typeface="BIZ UDPゴシック"/>
+                <a:ea typeface="BIZ UDPゴシック"/>
+                <a:cs typeface="BIZ UDPゴシック"/>
               </a:rPr>
               <a:t>次回（10/30）に見せるもの</a:t>
             </a:r>
@@ -11248,8 +11686,11 @@
                 <a:solidFill>
                   <a:srgbClr val="24303F"/>
                 </a:solidFill>
-              </a:rPr>
-              <a:t>β版の操作デモ（記録 → 提案 → みらいミラー）／操作確認の結果（SUS・つまずいた点）／CHIIR 投稿版の原稿</a:t>
+                <a:latin typeface="BIZ UDPゴシック"/>
+                <a:ea typeface="BIZ UDPゴシック"/>
+                <a:cs typeface="BIZ UDPゴシック"/>
+              </a:rPr>
+              <a:t>ベータ版の操作デモ（記録 → 提案 → みらいミラー）／操作確認の結果（SUS・つまずいた点）／CHIIR 投稿版の原稿</a:t>
             </a:r>
           </a:p>
         </p:txBody>
@@ -11300,6 +11741,9 @@
                 <a:solidFill>
                   <a:srgbClr val="24303F"/>
                 </a:solidFill>
+                <a:latin typeface="BIZ UDPゴシック"/>
+                <a:ea typeface="BIZ UDPゴシック"/>
+                <a:cs typeface="BIZ UDPゴシック"/>
               </a:rPr>
               <a:t>前回からの進捗サマリー</a:t>
             </a:r>
@@ -11318,9 +11762,14 @@
         </p:nvSpPr>
         <p:spPr/>
         <p:txBody>
-          <a:bodyPr/>
-          <a:p>
-            <a:r>
+          <a:bodyPr lIns="27432" rIns="0" wrap="none"/>
+          <a:p>
+            <a:r>
+              <a:rPr sz="900">
+                <a:latin typeface="BIZ UDPゴシック"/>
+                <a:ea typeface="BIZ UDPゴシック"/>
+                <a:cs typeface="BIZ UDPゴシック"/>
+              </a:rPr>
               <a:t>2026/10/16</a:t>
             </a:r>
           </a:p>
@@ -11341,7 +11790,11 @@
           <a:bodyPr/>
           <a:p>
             <a:fld id="{B6F15528-21DE-4FAA-801E-634DDDAF4B2B}" type="slidenum">
-              <a:rPr lang="en-US"/>
+              <a:rPr lang="en-US">
+                <a:latin typeface="BIZ UDPゴシック"/>
+                <a:ea typeface="BIZ UDPゴシック"/>
+                <a:cs typeface="BIZ UDPゴシック"/>
+              </a:rPr>
               <a:t>2</a:t>
             </a:fld>
           </a:p>
@@ -11424,6 +11877,9 @@
                 <a:solidFill>
                   <a:srgbClr val="5A6676"/>
                 </a:solidFill>
+                <a:latin typeface="BIZ UDPゴシック"/>
+                <a:ea typeface="BIZ UDPゴシック"/>
+                <a:cs typeface="BIZ UDPゴシック"/>
               </a:rPr>
               <a:t>前回（9月）までの到達点</a:t>
             </a:r>
@@ -11459,7 +11915,7 @@
               <a:buClr>
                 <a:srgbClr val="7A8594"/>
               </a:buClr>
-              <a:buFont typeface="Arial"/>
+              <a:buFont typeface="BIZ UDPゴシック"/>
               <a:buChar char="•"/>
             </a:pPr>
             <a:r>
@@ -11467,6 +11923,9 @@
                 <a:solidFill>
                   <a:srgbClr val="5A6676"/>
                 </a:solidFill>
+                <a:latin typeface="BIZ UDPゴシック"/>
+                <a:ea typeface="BIZ UDPゴシック"/>
+                <a:cs typeface="BIZ UDPゴシック"/>
               </a:rPr>
               <a:t>予備調査215名の再分析（回答の向きの確認・4タイプ分析）</a:t>
             </a:r>
@@ -11479,7 +11938,7 @@
               <a:buClr>
                 <a:srgbClr val="7A8594"/>
               </a:buClr>
-              <a:buFont typeface="Arial"/>
+              <a:buFont typeface="BIZ UDPゴシック"/>
               <a:buChar char="•"/>
             </a:pPr>
             <a:r>
@@ -11487,6 +11946,9 @@
                 <a:solidFill>
                   <a:srgbClr val="5A6676"/>
                 </a:solidFill>
+                <a:latin typeface="BIZ UDPゴシック"/>
+                <a:ea typeface="BIZ UDPゴシック"/>
+                <a:cs typeface="BIZ UDPゴシック"/>
               </a:rPr>
               <a:t>研究計画書を改訂（9/27版）：RQ1〜3、3群の無作為化比較実験</a:t>
             </a:r>
@@ -11499,7 +11961,7 @@
               <a:buClr>
                 <a:srgbClr val="7A8594"/>
               </a:buClr>
-              <a:buFont typeface="Arial"/>
+              <a:buFont typeface="BIZ UDPゴシック"/>
               <a:buChar char="•"/>
             </a:pPr>
             <a:r>
@@ -11507,6 +11969,9 @@
                 <a:solidFill>
                   <a:srgbClr val="5A6676"/>
                 </a:solidFill>
+                <a:latin typeface="BIZ UDPゴシック"/>
+                <a:ea typeface="BIZ UDPゴシック"/>
+                <a:cs typeface="BIZ UDPゴシック"/>
               </a:rPr>
               <a:t>Web版の試用版を作成</a:t>
             </a:r>
@@ -11610,6 +12075,9 @@
                 <a:solidFill>
                   <a:srgbClr val="FFFFFF"/>
                 </a:solidFill>
+                <a:latin typeface="BIZ UDPゴシック"/>
+                <a:ea typeface="BIZ UDPゴシック"/>
+                <a:cs typeface="BIZ UDPゴシック"/>
               </a:rPr>
               <a:t>完了</a:t>
             </a:r>
@@ -11649,6 +12117,9 @@
                 <a:solidFill>
                   <a:srgbClr val="0B3C6E"/>
                 </a:solidFill>
+                <a:latin typeface="BIZ UDPゴシック"/>
+                <a:ea typeface="BIZ UDPゴシック"/>
+                <a:cs typeface="BIZ UDPゴシック"/>
               </a:rPr>
               <a:t>倫理審査の申請書を提出（10/9）</a:t>
             </a:r>
@@ -11665,6 +12136,9 @@
                 <a:solidFill>
                   <a:srgbClr val="5A6676"/>
                 </a:solidFill>
+                <a:latin typeface="BIZ UDPゴシック"/>
+                <a:ea typeface="BIZ UDPゴシック"/>
+                <a:cs typeface="BIZ UDPゴシック"/>
               </a:rPr>
               <a:t>顔写真の扱い・相談先の表示・撤回手続きを明記</a:t>
             </a:r>
@@ -11726,6 +12200,9 @@
                 <a:solidFill>
                   <a:srgbClr val="FFFFFF"/>
                 </a:solidFill>
+                <a:latin typeface="BIZ UDPゴシック"/>
+                <a:ea typeface="BIZ UDPゴシック"/>
+                <a:cs typeface="BIZ UDPゴシック"/>
               </a:rPr>
               <a:t>完了</a:t>
             </a:r>
@@ -11765,6 +12242,9 @@
                 <a:solidFill>
                   <a:srgbClr val="0B3C6E"/>
                 </a:solidFill>
+                <a:latin typeface="BIZ UDPゴシック"/>
+                <a:ea typeface="BIZ UDPゴシック"/>
+                <a:cs typeface="BIZ UDPゴシック"/>
               </a:rPr>
               <a:t>予測モデル v1.0 を固定</a:t>
             </a:r>
@@ -11781,6 +12261,9 @@
                 <a:solidFill>
                   <a:srgbClr val="5A6676"/>
                 </a:solidFill>
+                <a:latin typeface="BIZ UDPゴシック"/>
+                <a:ea typeface="BIZ UDPゴシック"/>
+                <a:cs typeface="BIZ UDPゴシック"/>
               </a:rPr>
               <a:t>10分割交差検証で精度を確認し、版番号をつけて凍結</a:t>
             </a:r>
@@ -11842,6 +12325,9 @@
                 <a:solidFill>
                   <a:srgbClr val="FFFFFF"/>
                 </a:solidFill>
+                <a:latin typeface="BIZ UDPゴシック"/>
+                <a:ea typeface="BIZ UDPゴシック"/>
+                <a:cs typeface="BIZ UDPゴシック"/>
               </a:rPr>
               <a:t>完了</a:t>
             </a:r>
@@ -11881,6 +12367,9 @@
                 <a:solidFill>
                   <a:srgbClr val="0B3C6E"/>
                 </a:solidFill>
+                <a:latin typeface="BIZ UDPゴシック"/>
+                <a:ea typeface="BIZ UDPゴシック"/>
+                <a:cs typeface="BIZ UDPゴシック"/>
               </a:rPr>
               <a:t>アプリの土台を実装（React Native / Expo）</a:t>
             </a:r>
@@ -11897,6 +12386,9 @@
                 <a:solidFill>
                   <a:srgbClr val="5A6676"/>
                 </a:solidFill>
+                <a:latin typeface="BIZ UDPゴシック"/>
+                <a:ea typeface="BIZ UDPゴシック"/>
+                <a:cs typeface="BIZ UDPゴシック"/>
               </a:rPr>
               <a:t>毎日の記録画面・TIPI-J・匿名IDでのデータ送信</a:t>
             </a:r>
@@ -11958,6 +12450,9 @@
                 <a:solidFill>
                   <a:srgbClr val="FFFFFF"/>
                 </a:solidFill>
+                <a:latin typeface="BIZ UDPゴシック"/>
+                <a:ea typeface="BIZ UDPゴシック"/>
+                <a:cs typeface="BIZ UDPゴシック"/>
               </a:rPr>
               <a:t>新規</a:t>
             </a:r>
@@ -11997,6 +12492,9 @@
                 <a:solidFill>
                   <a:srgbClr val="0B3C6E"/>
                 </a:solidFill>
+                <a:latin typeface="BIZ UDPゴシック"/>
+                <a:ea typeface="BIZ UDPゴシック"/>
+                <a:cs typeface="BIZ UDPゴシック"/>
               </a:rPr>
               <a:t>OshiFit v2 を設計：4つの新しい仕組み</a:t>
             </a:r>
@@ -12013,6 +12511,9 @@
                 <a:solidFill>
                   <a:srgbClr val="5A6676"/>
                 </a:solidFill>
+                <a:latin typeface="BIZ UDPゴシック"/>
+                <a:ea typeface="BIZ UDPゴシック"/>
+                <a:cs typeface="BIZ UDPゴシック"/>
               </a:rPr>
               <a:t>ベイズ個人ツイン／ゆらぎアバター／リバランス提案／疲れの中身キュー</a:t>
             </a:r>
@@ -12074,6 +12575,9 @@
                 <a:solidFill>
                   <a:srgbClr val="FFFFFF"/>
                 </a:solidFill>
+                <a:latin typeface="BIZ UDPゴシック"/>
+                <a:ea typeface="BIZ UDPゴシック"/>
+                <a:cs typeface="BIZ UDPゴシック"/>
               </a:rPr>
               <a:t>進行中</a:t>
             </a:r>
@@ -12113,6 +12617,9 @@
                 <a:solidFill>
                   <a:srgbClr val="0B3C6E"/>
                 </a:solidFill>
+                <a:latin typeface="BIZ UDPゴシック"/>
+                <a:ea typeface="BIZ UDPゴシック"/>
+                <a:cs typeface="BIZ UDPゴシック"/>
               </a:rPr>
               <a:t>CHIIR 2027 の原稿</a:t>
             </a:r>
@@ -12129,6 +12636,9 @@
                 <a:solidFill>
                   <a:srgbClr val="5A6676"/>
                 </a:solidFill>
+                <a:latin typeface="BIZ UDPゴシック"/>
+                <a:ea typeface="BIZ UDPゴシック"/>
+                <a:cs typeface="BIZ UDPゴシック"/>
               </a:rPr>
               <a:t>構成と図を作成中（締切 10/29）</a:t>
             </a:r>
@@ -12190,6 +12700,9 @@
                 <a:solidFill>
                   <a:srgbClr val="0B3C6E"/>
                 </a:solidFill>
+                <a:latin typeface="BIZ UDPゴシック"/>
+                <a:ea typeface="BIZ UDPゴシック"/>
+                <a:cs typeface="BIZ UDPゴシック"/>
               </a:rPr>
               <a:t>今回の主張：予測の「不確かさ」を隠さずアバターで見せ、記録を続ける動機に変える</a:t>
             </a:r>
@@ -12242,6 +12755,9 @@
                 <a:solidFill>
                   <a:srgbClr val="24303F"/>
                 </a:solidFill>
+                <a:latin typeface="BIZ UDPゴシック"/>
+                <a:ea typeface="BIZ UDPゴシック"/>
+                <a:cs typeface="BIZ UDPゴシック"/>
               </a:rPr>
               <a:t>全体スケジュールと現在地</a:t>
             </a:r>
@@ -12260,9 +12776,14 @@
         </p:nvSpPr>
         <p:spPr/>
         <p:txBody>
-          <a:bodyPr/>
-          <a:p>
-            <a:r>
+          <a:bodyPr lIns="27432" rIns="0" wrap="none"/>
+          <a:p>
+            <a:r>
+              <a:rPr sz="900">
+                <a:latin typeface="BIZ UDPゴシック"/>
+                <a:ea typeface="BIZ UDPゴシック"/>
+                <a:cs typeface="BIZ UDPゴシック"/>
+              </a:rPr>
               <a:t>2026/10/16</a:t>
             </a:r>
           </a:p>
@@ -12283,7 +12804,11 @@
           <a:bodyPr/>
           <a:p>
             <a:fld id="{B6F15528-21DE-4FAA-801E-634DDDAF4B2B}" type="slidenum">
-              <a:rPr lang="en-US"/>
+              <a:rPr lang="en-US">
+                <a:latin typeface="BIZ UDPゴシック"/>
+                <a:ea typeface="BIZ UDPゴシック"/>
+                <a:cs typeface="BIZ UDPゴシック"/>
+              </a:rPr>
               <a:t>3</a:t>
             </a:fld>
           </a:p>
@@ -12322,6 +12847,9 @@
                 <a:solidFill>
                   <a:srgbClr val="5A6676"/>
                 </a:solidFill>
+                <a:latin typeface="BIZ UDPゴシック"/>
+                <a:ea typeface="BIZ UDPゴシック"/>
+                <a:cs typeface="BIZ UDPゴシック"/>
               </a:rPr>
               <a:t>10月</a:t>
             </a:r>
@@ -12396,6 +12924,9 @@
                 <a:solidFill>
                   <a:srgbClr val="5A6676"/>
                 </a:solidFill>
+                <a:latin typeface="BIZ UDPゴシック"/>
+                <a:ea typeface="BIZ UDPゴシック"/>
+                <a:cs typeface="BIZ UDPゴシック"/>
               </a:rPr>
               <a:t>11月</a:t>
             </a:r>
@@ -12470,6 +13001,9 @@
                 <a:solidFill>
                   <a:srgbClr val="5A6676"/>
                 </a:solidFill>
+                <a:latin typeface="BIZ UDPゴシック"/>
+                <a:ea typeface="BIZ UDPゴシック"/>
+                <a:cs typeface="BIZ UDPゴシック"/>
               </a:rPr>
               <a:t>12月</a:t>
             </a:r>
@@ -12544,6 +13078,9 @@
                 <a:solidFill>
                   <a:srgbClr val="5A6676"/>
                 </a:solidFill>
+                <a:latin typeface="BIZ UDPゴシック"/>
+                <a:ea typeface="BIZ UDPゴシック"/>
+                <a:cs typeface="BIZ UDPゴシック"/>
               </a:rPr>
               <a:t>1月</a:t>
             </a:r>
@@ -12618,6 +13155,9 @@
                 <a:solidFill>
                   <a:srgbClr val="5A6676"/>
                 </a:solidFill>
+                <a:latin typeface="BIZ UDPゴシック"/>
+                <a:ea typeface="BIZ UDPゴシック"/>
+                <a:cs typeface="BIZ UDPゴシック"/>
               </a:rPr>
               <a:t>2月</a:t>
             </a:r>
@@ -12692,6 +13232,9 @@
                 <a:solidFill>
                   <a:srgbClr val="5A6676"/>
                 </a:solidFill>
+                <a:latin typeface="BIZ UDPゴシック"/>
+                <a:ea typeface="BIZ UDPゴシック"/>
+                <a:cs typeface="BIZ UDPゴシック"/>
               </a:rPr>
               <a:t>3月</a:t>
             </a:r>
@@ -12766,6 +13309,9 @@
                 <a:solidFill>
                   <a:srgbClr val="0B3C6E"/>
                 </a:solidFill>
+                <a:latin typeface="BIZ UDPゴシック"/>
+                <a:ea typeface="BIZ UDPゴシック"/>
+                <a:cs typeface="BIZ UDPゴシック"/>
               </a:rPr>
               <a:t>システム開発</a:t>
             </a:r>
@@ -12893,8 +13439,11 @@
                 <a:solidFill>
                   <a:srgbClr val="0B3C6E"/>
                 </a:solidFill>
-              </a:rPr>
-              <a:t>設計 → β版</a:t>
+                <a:latin typeface="BIZ UDPゴシック"/>
+                <a:ea typeface="BIZ UDPゴシック"/>
+                <a:cs typeface="BIZ UDPゴシック"/>
+              </a:rPr>
+              <a:t>設計 → ベータ版</a:t>
             </a:r>
           </a:p>
         </p:txBody>
@@ -12932,6 +13481,9 @@
                 <a:solidFill>
                   <a:srgbClr val="0B3C6E"/>
                 </a:solidFill>
+                <a:latin typeface="BIZ UDPゴシック"/>
+                <a:ea typeface="BIZ UDPゴシック"/>
+                <a:cs typeface="BIZ UDPゴシック"/>
               </a:rPr>
               <a:t>倫理審査・募集</a:t>
             </a:r>
@@ -13059,6 +13611,9 @@
                 <a:solidFill>
                   <a:srgbClr val="0B3C6E"/>
                 </a:solidFill>
+                <a:latin typeface="BIZ UDPゴシック"/>
+                <a:ea typeface="BIZ UDPゴシック"/>
+                <a:cs typeface="BIZ UDPゴシック"/>
               </a:rPr>
               <a:t>審査</a:t>
             </a:r>
@@ -13142,6 +13697,9 @@
                 <a:solidFill>
                   <a:srgbClr val="0B3C6E"/>
                 </a:solidFill>
+                <a:latin typeface="BIZ UDPゴシック"/>
+                <a:ea typeface="BIZ UDPゴシック"/>
+                <a:cs typeface="BIZ UDPゴシック"/>
               </a:rPr>
               <a:t>募集</a:t>
             </a:r>
@@ -13181,6 +13739,9 @@
                 <a:solidFill>
                   <a:srgbClr val="0B3C6E"/>
                 </a:solidFill>
+                <a:latin typeface="BIZ UDPゴシック"/>
+                <a:ea typeface="BIZ UDPゴシック"/>
+                <a:cs typeface="BIZ UDPゴシック"/>
               </a:rPr>
               <a:t>本実験（6週間）</a:t>
             </a:r>
@@ -13264,6 +13825,9 @@
                 <a:solidFill>
                   <a:srgbClr val="0B3C6E"/>
                 </a:solidFill>
+                <a:latin typeface="BIZ UDPゴシック"/>
+                <a:ea typeface="BIZ UDPゴシック"/>
+                <a:cs typeface="BIZ UDPゴシック"/>
               </a:rPr>
               <a:t>記録のみ</a:t>
             </a:r>
@@ -13347,6 +13911,9 @@
                 <a:solidFill>
                   <a:srgbClr val="0B3C6E"/>
                 </a:solidFill>
+                <a:latin typeface="BIZ UDPゴシック"/>
+                <a:ea typeface="BIZ UDPゴシック"/>
+                <a:cs typeface="BIZ UDPゴシック"/>
               </a:rPr>
               <a:t>介入（3群）</a:t>
             </a:r>
@@ -13386,6 +13953,9 @@
                 <a:solidFill>
                   <a:srgbClr val="0B3C6E"/>
                 </a:solidFill>
+                <a:latin typeface="BIZ UDPゴシック"/>
+                <a:ea typeface="BIZ UDPゴシック"/>
+                <a:cs typeface="BIZ UDPゴシック"/>
               </a:rPr>
               <a:t>解析・修論</a:t>
             </a:r>
@@ -13469,6 +14039,9 @@
                 <a:solidFill>
                   <a:srgbClr val="0B3C6E"/>
                 </a:solidFill>
+                <a:latin typeface="BIZ UDPゴシック"/>
+                <a:ea typeface="BIZ UDPゴシック"/>
+                <a:cs typeface="BIZ UDPゴシック"/>
               </a:rPr>
               <a:t>解析 → 執筆</a:t>
             </a:r>
@@ -13508,6 +14081,9 @@
                 <a:solidFill>
                   <a:srgbClr val="0B3C6E"/>
                 </a:solidFill>
+                <a:latin typeface="BIZ UDPゴシック"/>
+                <a:ea typeface="BIZ UDPゴシック"/>
+                <a:cs typeface="BIZ UDPゴシック"/>
               </a:rPr>
               <a:t>対外発表</a:t>
             </a:r>
@@ -13591,6 +14167,9 @@
                 <a:solidFill>
                   <a:srgbClr val="24303F"/>
                 </a:solidFill>
+                <a:latin typeface="BIZ UDPゴシック"/>
+                <a:ea typeface="BIZ UDPゴシック"/>
+                <a:cs typeface="BIZ UDPゴシック"/>
               </a:rPr>
               <a:t>CHIIR投稿</a:t>
             </a:r>
@@ -13607,6 +14186,9 @@
                 <a:solidFill>
                   <a:srgbClr val="24303F"/>
                 </a:solidFill>
+                <a:latin typeface="BIZ UDPゴシック"/>
+                <a:ea typeface="BIZ UDPゴシック"/>
+                <a:cs typeface="BIZ UDPゴシック"/>
               </a:rPr>
               <a:t>10/29</a:t>
             </a:r>
@@ -13690,6 +14272,9 @@
                 <a:solidFill>
                   <a:srgbClr val="24303F"/>
                 </a:solidFill>
+                <a:latin typeface="BIZ UDPゴシック"/>
+                <a:ea typeface="BIZ UDPゴシック"/>
+                <a:cs typeface="BIZ UDPゴシック"/>
               </a:rPr>
               <a:t>修論提出</a:t>
             </a:r>
@@ -13706,6 +14291,9 @@
                 <a:solidFill>
                   <a:srgbClr val="24303F"/>
                 </a:solidFill>
+                <a:latin typeface="BIZ UDPゴシック"/>
+                <a:ea typeface="BIZ UDPゴシック"/>
+                <a:cs typeface="BIZ UDPゴシック"/>
               </a:rPr>
               <a:t>1/29</a:t>
             </a:r>
@@ -13789,6 +14377,9 @@
                 <a:solidFill>
                   <a:srgbClr val="24303F"/>
                 </a:solidFill>
+                <a:latin typeface="BIZ UDPゴシック"/>
+                <a:ea typeface="BIZ UDPゴシック"/>
+                <a:cs typeface="BIZ UDPゴシック"/>
               </a:rPr>
               <a:t>公聴会</a:t>
             </a:r>
@@ -13805,6 +14396,9 @@
                 <a:solidFill>
                   <a:srgbClr val="24303F"/>
                 </a:solidFill>
+                <a:latin typeface="BIZ UDPゴシック"/>
+                <a:ea typeface="BIZ UDPゴシック"/>
+                <a:cs typeface="BIZ UDPゴシック"/>
               </a:rPr>
               <a:t>2/17</a:t>
             </a:r>
@@ -13888,6 +14482,9 @@
                 <a:solidFill>
                   <a:srgbClr val="24303F"/>
                 </a:solidFill>
+                <a:latin typeface="BIZ UDPゴシック"/>
+                <a:ea typeface="BIZ UDPゴシック"/>
+                <a:cs typeface="BIZ UDPゴシック"/>
               </a:rPr>
               <a:t>CHIIR</a:t>
             </a:r>
@@ -13904,6 +14501,9 @@
                 <a:solidFill>
                   <a:srgbClr val="24303F"/>
                 </a:solidFill>
+                <a:latin typeface="BIZ UDPゴシック"/>
+                <a:ea typeface="BIZ UDPゴシック"/>
+                <a:cs typeface="BIZ UDPゴシック"/>
               </a:rPr>
               <a:t>3/7–11</a:t>
             </a:r>
@@ -14001,6 +14601,9 @@
                 <a:solidFill>
                   <a:srgbClr val="FFFFFF"/>
                 </a:solidFill>
+                <a:latin typeface="BIZ UDPゴシック"/>
+                <a:ea typeface="BIZ UDPゴシック"/>
+                <a:cs typeface="BIZ UDPゴシック"/>
               </a:rPr>
               <a:t>いまここ 10/16</a:t>
             </a:r>
@@ -14150,8 +14753,11 @@
                 <a:solidFill>
                   <a:srgbClr val="0B3C6E"/>
                 </a:solidFill>
-              </a:rPr>
-              <a:t>11月2日（月）に本実験を始めるには、残り約2週間で「β版の完成」と「操作確認」を終える必要がある</a:t>
+                <a:latin typeface="BIZ UDPゴシック"/>
+                <a:ea typeface="BIZ UDPゴシック"/>
+                <a:cs typeface="BIZ UDPゴシック"/>
+              </a:rPr>
+              <a:t>11月2日（月）に本実験を始めるには、残り約2週間で「ベータ版の完成」と「操作確認」を終える必要がある</a:t>
             </a:r>
           </a:p>
           <a:p>
@@ -14166,6 +14772,9 @@
                 <a:solidFill>
                   <a:srgbClr val="5A6676"/>
                 </a:solidFill>
+                <a:latin typeface="BIZ UDPゴシック"/>
+                <a:ea typeface="BIZ UDPゴシック"/>
+                <a:cs typeface="BIZ UDPゴシック"/>
               </a:rPr>
               <a:t>6週間の実験＋解析を修論提出（1/29）に間に合わせるための逆算。倫理審査が遅れた場合は群B・Cの2群に縮小</a:t>
             </a:r>
@@ -14218,6 +14827,9 @@
                 <a:solidFill>
                   <a:srgbClr val="24303F"/>
                 </a:solidFill>
+                <a:latin typeface="BIZ UDPゴシック"/>
+                <a:ea typeface="BIZ UDPゴシック"/>
+                <a:cs typeface="BIZ UDPゴシック"/>
               </a:rPr>
               <a:t>倫理審査の申請内容（10/9 提出）</a:t>
             </a:r>
@@ -14236,9 +14848,14 @@
         </p:nvSpPr>
         <p:spPr/>
         <p:txBody>
-          <a:bodyPr/>
-          <a:p>
-            <a:r>
+          <a:bodyPr lIns="27432" rIns="0" wrap="none"/>
+          <a:p>
+            <a:r>
+              <a:rPr sz="900">
+                <a:latin typeface="BIZ UDPゴシック"/>
+                <a:ea typeface="BIZ UDPゴシック"/>
+                <a:cs typeface="BIZ UDPゴシック"/>
+              </a:rPr>
               <a:t>2026/10/16</a:t>
             </a:r>
           </a:p>
@@ -14259,7 +14876,11 @@
           <a:bodyPr/>
           <a:p>
             <a:fld id="{B6F15528-21DE-4FAA-801E-634DDDAF4B2B}" type="slidenum">
-              <a:rPr lang="en-US"/>
+              <a:rPr lang="en-US">
+                <a:latin typeface="BIZ UDPゴシック"/>
+                <a:ea typeface="BIZ UDPゴシック"/>
+                <a:cs typeface="BIZ UDPゴシック"/>
+              </a:rPr>
               <a:t>4</a:t>
             </a:fld>
           </a:p>
@@ -14416,6 +15037,9 @@
                 <a:solidFill>
                   <a:srgbClr val="0B3C6E"/>
                 </a:solidFill>
+                <a:latin typeface="BIZ UDPゴシック"/>
+                <a:ea typeface="BIZ UDPゴシック"/>
+                <a:cs typeface="BIZ UDPゴシック"/>
               </a:rPr>
               <a:t>顔写真の扱い</a:t>
             </a:r>
@@ -14455,6 +15079,9 @@
                 <a:solidFill>
                   <a:srgbClr val="24303F"/>
                 </a:solidFill>
+                <a:latin typeface="BIZ UDPゴシック"/>
+                <a:ea typeface="BIZ UDPゴシック"/>
+                <a:cs typeface="BIZ UDPゴシック"/>
               </a:rPr>
               <a:t>端末の中だけで処理し、アバター生成後すぐに破棄。サーバーへは送らない。写真を使わない作成方法も用意</a:t>
             </a:r>
@@ -14612,6 +15239,9 @@
                 <a:solidFill>
                   <a:srgbClr val="0B3C6E"/>
                 </a:solidFill>
+                <a:latin typeface="BIZ UDPゴシック"/>
+                <a:ea typeface="BIZ UDPゴシック"/>
+                <a:cs typeface="BIZ UDPゴシック"/>
               </a:rPr>
               <a:t>同意と撤回</a:t>
             </a:r>
@@ -14651,6 +15281,9 @@
                 <a:solidFill>
                   <a:srgbClr val="24303F"/>
                 </a:solidFill>
+                <a:latin typeface="BIZ UDPゴシック"/>
+                <a:ea typeface="BIZ UDPゴシック"/>
+                <a:cs typeface="BIZ UDPゴシック"/>
               </a:rPr>
               <a:t>参加は任意。いつでも撤回とデータ削除ができる。記録は匿名IDで管理し、氏名とは切り離す</a:t>
             </a:r>
@@ -14808,6 +15441,9 @@
                 <a:solidFill>
                   <a:srgbClr val="0B3C6E"/>
                 </a:solidFill>
+                <a:latin typeface="BIZ UDPゴシック"/>
+                <a:ea typeface="BIZ UDPゴシック"/>
+                <a:cs typeface="BIZ UDPゴシック"/>
               </a:rPr>
               <a:t>つらさへの配慮</a:t>
             </a:r>
@@ -14847,6 +15483,9 @@
                 <a:solidFill>
                   <a:srgbClr val="24303F"/>
                 </a:solidFill>
+                <a:latin typeface="BIZ UDPゴシック"/>
+                <a:ea typeface="BIZ UDPゴシック"/>
+                <a:cs typeface="BIZ UDPゴシック"/>
               </a:rPr>
               <a:t>WHO-5 素点が13点未満、または強い疲れの記録があれば相談先を表示し、利用の継続を求めない</a:t>
             </a:r>
@@ -15004,6 +15643,9 @@
                 <a:solidFill>
                   <a:srgbClr val="0B3C6E"/>
                 </a:solidFill>
+                <a:latin typeface="BIZ UDPゴシック"/>
+                <a:ea typeface="BIZ UDPゴシック"/>
+                <a:cs typeface="BIZ UDPゴシック"/>
               </a:rPr>
               <a:t>予測の説明</a:t>
             </a:r>
@@ -15043,6 +15685,9 @@
                 <a:solidFill>
                   <a:srgbClr val="24303F"/>
                 </a:solidFill>
+                <a:latin typeface="BIZ UDPゴシック"/>
+                <a:ea typeface="BIZ UDPゴシック"/>
+                <a:cs typeface="BIZ UDPゴシック"/>
               </a:rPr>
               <a:t>予測値は「見込み」であることを常に表示。終了後に予測の精度を参加者へ説明する</a:t>
             </a:r>
@@ -15102,6 +15747,9 @@
                 <a:solidFill>
                   <a:srgbClr val="FFFFFF"/>
                 </a:solidFill>
+                <a:latin typeface="BIZ UDPゴシック"/>
+                <a:ea typeface="BIZ UDPゴシック"/>
+                <a:cs typeface="BIZ UDPゴシック"/>
               </a:rPr>
               <a:t>10/9</a:t>
             </a:r>
@@ -15141,6 +15789,9 @@
                 <a:solidFill>
                   <a:srgbClr val="0B3C6E"/>
                 </a:solidFill>
+                <a:latin typeface="BIZ UDPゴシック"/>
+                <a:ea typeface="BIZ UDPゴシック"/>
+                <a:cs typeface="BIZ UDPゴシック"/>
               </a:rPr>
               <a:t>申請書を提出</a:t>
             </a:r>
@@ -15236,6 +15887,9 @@
                 <a:solidFill>
                   <a:srgbClr val="FFFFFF"/>
                 </a:solidFill>
+                <a:latin typeface="BIZ UDPゴシック"/>
+                <a:ea typeface="BIZ UDPゴシック"/>
+                <a:cs typeface="BIZ UDPゴシック"/>
               </a:rPr>
               <a:t>10/21</a:t>
             </a:r>
@@ -15275,6 +15929,9 @@
                 <a:solidFill>
                   <a:srgbClr val="0B3C6E"/>
                 </a:solidFill>
+                <a:latin typeface="BIZ UDPゴシック"/>
+                <a:ea typeface="BIZ UDPゴシック"/>
+                <a:cs typeface="BIZ UDPゴシック"/>
               </a:rPr>
               <a:t>審査会（予定）</a:t>
             </a:r>
@@ -15370,6 +16027,9 @@
                 <a:solidFill>
                   <a:srgbClr val="FFFFFF"/>
                 </a:solidFill>
+                <a:latin typeface="BIZ UDPゴシック"/>
+                <a:ea typeface="BIZ UDPゴシック"/>
+                <a:cs typeface="BIZ UDPゴシック"/>
               </a:rPr>
               <a:t>承認後</a:t>
             </a:r>
@@ -15409,6 +16069,9 @@
                 <a:solidFill>
                   <a:srgbClr val="0B3C6E"/>
                 </a:solidFill>
+                <a:latin typeface="BIZ UDPゴシック"/>
+                <a:ea typeface="BIZ UDPゴシック"/>
+                <a:cs typeface="BIZ UDPゴシック"/>
               </a:rPr>
               <a:t>募集を開始</a:t>
             </a:r>
@@ -15461,6 +16124,9 @@
                 <a:solidFill>
                   <a:srgbClr val="24303F"/>
                 </a:solidFill>
+                <a:latin typeface="BIZ UDPゴシック"/>
+                <a:ea typeface="BIZ UDPゴシック"/>
+                <a:cs typeface="BIZ UDPゴシック"/>
               </a:rPr>
               <a:t>予測モデル v1.0 を固定</a:t>
             </a:r>
@@ -15479,9 +16145,14 @@
         </p:nvSpPr>
         <p:spPr/>
         <p:txBody>
-          <a:bodyPr/>
-          <a:p>
-            <a:r>
+          <a:bodyPr lIns="27432" rIns="0" wrap="none"/>
+          <a:p>
+            <a:r>
+              <a:rPr sz="900">
+                <a:latin typeface="BIZ UDPゴシック"/>
+                <a:ea typeface="BIZ UDPゴシック"/>
+                <a:cs typeface="BIZ UDPゴシック"/>
+              </a:rPr>
               <a:t>2026/10/16</a:t>
             </a:r>
           </a:p>
@@ -15502,7 +16173,11 @@
           <a:bodyPr/>
           <a:p>
             <a:fld id="{B6F15528-21DE-4FAA-801E-634DDDAF4B2B}" type="slidenum">
-              <a:rPr lang="en-US"/>
+              <a:rPr lang="en-US">
+                <a:latin typeface="BIZ UDPゴシック"/>
+                <a:ea typeface="BIZ UDPゴシック"/>
+                <a:cs typeface="BIZ UDPゴシック"/>
+              </a:rPr>
               <a:t>5</a:t>
             </a:fld>
           </a:p>
@@ -15603,6 +16278,9 @@
                 <a:solidFill>
                   <a:srgbClr val="E07A10"/>
                 </a:solidFill>
+                <a:latin typeface="BIZ UDPゴシック"/>
+                <a:ea typeface="BIZ UDPゴシック"/>
+                <a:cs typeface="BIZ UDPゴシック"/>
               </a:rPr>
               <a:t>同じ行動が「充実」と「推し疲れ」を両方押し上げる</a:t>
             </a:r>
@@ -15619,6 +16297,9 @@
                 <a:solidFill>
                   <a:srgbClr val="24303F"/>
                 </a:solidFill>
+                <a:latin typeface="BIZ UDPゴシック"/>
+                <a:ea typeface="BIZ UDPゴシック"/>
+                <a:cs typeface="BIZ UDPゴシック"/>
               </a:rPr>
               <a:t>→ 一律に「減らす」提案は楽しさまで削ってしまう。本人の希望と疲れの中身に合わせた提案が必要</a:t>
             </a:r>
@@ -15667,6 +16348,9 @@
                           <a:solidFill>
                             <a:srgbClr val="FFFFFF"/>
                           </a:solidFill>
+                          <a:latin typeface="BIZ UDPゴシック"/>
+                          <a:ea typeface="BIZ UDPゴシック"/>
+                          <a:cs typeface="BIZ UDPゴシック"/>
                         </a:rPr>
                         <a:t>出力</a:t>
                       </a:r>
@@ -15716,6 +16400,9 @@
                           <a:solidFill>
                             <a:srgbClr val="FFFFFF"/>
                           </a:solidFill>
+                          <a:latin typeface="BIZ UDPゴシック"/>
+                          <a:ea typeface="BIZ UDPゴシック"/>
+                          <a:cs typeface="BIZ UDPゴシック"/>
                         </a:rPr>
                         <a:t>説明率</a:t>
                       </a:r>
@@ -15765,6 +16452,9 @@
                           <a:solidFill>
                             <a:srgbClr val="FFFFFF"/>
                           </a:solidFill>
+                          <a:latin typeface="BIZ UDPゴシック"/>
+                          <a:ea typeface="BIZ UDPゴシック"/>
+                          <a:cs typeface="BIZ UDPゴシック"/>
                         </a:rPr>
                         <a:t>誤差（5段階）</a:t>
                       </a:r>
@@ -15816,6 +16506,9 @@
                           <a:solidFill>
                             <a:srgbClr val="24303F"/>
                           </a:solidFill>
+                          <a:latin typeface="BIZ UDPゴシック"/>
+                          <a:ea typeface="BIZ UDPゴシック"/>
+                          <a:cs typeface="BIZ UDPゴシック"/>
                         </a:rPr>
                         <a:t>幸福度（充実）</a:t>
                       </a:r>
@@ -15865,6 +16558,9 @@
                           <a:solidFill>
                             <a:srgbClr val="24303F"/>
                           </a:solidFill>
+                          <a:latin typeface="BIZ UDPゴシック"/>
+                          <a:ea typeface="BIZ UDPゴシック"/>
+                          <a:cs typeface="BIZ UDPゴシック"/>
                         </a:rPr>
                         <a:t>約27%</a:t>
                       </a:r>
@@ -15914,6 +16610,9 @@
                           <a:solidFill>
                             <a:srgbClr val="24303F"/>
                           </a:solidFill>
+                          <a:latin typeface="BIZ UDPゴシック"/>
+                          <a:ea typeface="BIZ UDPゴシック"/>
+                          <a:cs typeface="BIZ UDPゴシック"/>
                         </a:rPr>
                         <a:t>±0.71</a:t>
                       </a:r>
@@ -15965,6 +16664,9 @@
                           <a:solidFill>
                             <a:srgbClr val="24303F"/>
                           </a:solidFill>
+                          <a:latin typeface="BIZ UDPゴシック"/>
+                          <a:ea typeface="BIZ UDPゴシック"/>
+                          <a:cs typeface="BIZ UDPゴシック"/>
                         </a:rPr>
                         <a:t>推し疲れ</a:t>
                       </a:r>
@@ -16014,6 +16716,9 @@
                           <a:solidFill>
                             <a:srgbClr val="24303F"/>
                           </a:solidFill>
+                          <a:latin typeface="BIZ UDPゴシック"/>
+                          <a:ea typeface="BIZ UDPゴシック"/>
+                          <a:cs typeface="BIZ UDPゴシック"/>
                         </a:rPr>
                         <a:t>約11%</a:t>
                       </a:r>
@@ -16063,6 +16768,9 @@
                           <a:solidFill>
                             <a:srgbClr val="24303F"/>
                           </a:solidFill>
+                          <a:latin typeface="BIZ UDPゴシック"/>
+                          <a:ea typeface="BIZ UDPゴシック"/>
+                          <a:cs typeface="BIZ UDPゴシック"/>
                         </a:rPr>
                         <a:t>±0.92</a:t>
                       </a:r>
@@ -16132,6 +16840,9 @@
                 <a:solidFill>
                   <a:srgbClr val="5A6676"/>
                 </a:solidFill>
+                <a:latin typeface="BIZ UDPゴシック"/>
+                <a:ea typeface="BIZ UDPゴシック"/>
+                <a:cs typeface="BIZ UDPゴシック"/>
               </a:rPr>
               <a:t>10分割交差検証（入力：頻度・没入・きっかけ・TIPI-J）</a:t>
             </a:r>
@@ -16289,6 +17000,9 @@
                 <a:solidFill>
                   <a:srgbClr val="0B3C6E"/>
                 </a:solidFill>
+                <a:latin typeface="BIZ UDPゴシック"/>
+                <a:ea typeface="BIZ UDPゴシック"/>
+                <a:cs typeface="BIZ UDPゴシック"/>
               </a:rPr>
               <a:t>v1.0 として凍結したもの</a:t>
             </a:r>
@@ -16324,7 +17038,7 @@
               <a:buClr>
                 <a:srgbClr val="0099FF"/>
               </a:buClr>
-              <a:buFont typeface="Arial"/>
+              <a:buFont typeface="BIZ UDPゴシック"/>
               <a:buChar char="•"/>
             </a:pPr>
             <a:r>
@@ -16332,6 +17046,9 @@
                 <a:solidFill>
                   <a:srgbClr val="24303F"/>
                 </a:solidFill>
+                <a:latin typeface="BIZ UDPゴシック"/>
+                <a:ea typeface="BIZ UDPゴシック"/>
+                <a:cs typeface="BIZ UDPゴシック"/>
               </a:rPr>
               <a:t>係数・前処理・欠測の扱い</a:t>
             </a:r>
@@ -16344,7 +17061,7 @@
               <a:buClr>
                 <a:srgbClr val="0099FF"/>
               </a:buClr>
-              <a:buFont typeface="Arial"/>
+              <a:buFont typeface="BIZ UDPゴシック"/>
               <a:buChar char="•"/>
             </a:pPr>
             <a:r>
@@ -16352,6 +17069,9 @@
                 <a:solidFill>
                   <a:srgbClr val="24303F"/>
                 </a:solidFill>
+                <a:latin typeface="BIZ UDPゴシック"/>
+                <a:ea typeface="BIZ UDPゴシック"/>
+                <a:cs typeface="BIZ UDPゴシック"/>
               </a:rPr>
               <a:t>学習コードと乱数シード（Gitタグ model-v1.0）</a:t>
             </a:r>
@@ -16364,7 +17084,7 @@
               <a:buClr>
                 <a:srgbClr val="0099FF"/>
               </a:buClr>
-              <a:buFont typeface="Arial"/>
+              <a:buFont typeface="BIZ UDPゴシック"/>
               <a:buChar char="•"/>
             </a:pPr>
             <a:r>
@@ -16372,6 +17092,9 @@
                 <a:solidFill>
                   <a:srgbClr val="24303F"/>
                 </a:solidFill>
+                <a:latin typeface="BIZ UDPゴシック"/>
+                <a:ea typeface="BIZ UDPゴシック"/>
+                <a:cs typeface="BIZ UDPゴシック"/>
               </a:rPr>
               <a:t>予測区間の計算方法（80%区間）</a:t>
             </a:r>
@@ -16384,7 +17107,7 @@
               <a:buClr>
                 <a:srgbClr val="E8457C"/>
               </a:buClr>
-              <a:buFont typeface="Arial"/>
+              <a:buFont typeface="BIZ UDPゴシック"/>
               <a:buChar char="•"/>
             </a:pPr>
             <a:r>
@@ -16392,6 +17115,9 @@
                 <a:solidFill>
                   <a:srgbClr val="24303F"/>
                 </a:solidFill>
+                <a:latin typeface="BIZ UDPゴシック"/>
+                <a:ea typeface="BIZ UDPゴシック"/>
+                <a:cs typeface="BIZ UDPゴシック"/>
               </a:rPr>
               <a:t>本実験中はモデルを変えず、個人補正のみ行う</a:t>
             </a:r>
@@ -16444,6 +17170,9 @@
                 <a:solidFill>
                   <a:srgbClr val="24303F"/>
                 </a:solidFill>
+                <a:latin typeface="BIZ UDPゴシック"/>
+                <a:ea typeface="BIZ UDPゴシック"/>
+                <a:cs typeface="BIZ UDPゴシック"/>
               </a:rPr>
               <a:t>課題：精度の低い予測で「未来」をどう見せるか</a:t>
             </a:r>
@@ -16462,9 +17191,14 @@
         </p:nvSpPr>
         <p:spPr/>
         <p:txBody>
-          <a:bodyPr/>
-          <a:p>
-            <a:r>
+          <a:bodyPr lIns="27432" rIns="0" wrap="none"/>
+          <a:p>
+            <a:r>
+              <a:rPr sz="900">
+                <a:latin typeface="BIZ UDPゴシック"/>
+                <a:ea typeface="BIZ UDPゴシック"/>
+                <a:cs typeface="BIZ UDPゴシック"/>
+              </a:rPr>
               <a:t>2026/10/16</a:t>
             </a:r>
           </a:p>
@@ -16485,7 +17219,11 @@
           <a:bodyPr/>
           <a:p>
             <a:fld id="{B6F15528-21DE-4FAA-801E-634DDDAF4B2B}" type="slidenum">
-              <a:rPr lang="en-US"/>
+              <a:rPr lang="en-US">
+                <a:latin typeface="BIZ UDPゴシック"/>
+                <a:ea typeface="BIZ UDPゴシック"/>
+                <a:cs typeface="BIZ UDPゴシック"/>
+              </a:rPr>
               <a:t>6</a:t>
             </a:fld>
           </a:p>
@@ -16568,6 +17306,9 @@
                 <a:solidFill>
                   <a:srgbClr val="0B3C6E"/>
                 </a:solidFill>
+                <a:latin typeface="BIZ UDPゴシック"/>
+                <a:ea typeface="BIZ UDPゴシック"/>
+                <a:cs typeface="BIZ UDPゴシック"/>
               </a:rPr>
               <a:t>推し疲れの誤差は ±0.92（5段階）</a:t>
             </a:r>
@@ -16584,6 +17325,9 @@
                 <a:solidFill>
                   <a:srgbClr val="5A6676"/>
                 </a:solidFill>
+                <a:latin typeface="BIZ UDPゴシック"/>
+                <a:ea typeface="BIZ UDPゴシック"/>
+                <a:cs typeface="BIZ UDPゴシック"/>
               </a:rPr>
               <a:t>1人の未来として断定的に見せると、誤解や不安を招く</a:t>
             </a:r>
@@ -16783,6 +17527,9 @@
                 <a:solidFill>
                   <a:srgbClr val="12A38A"/>
                 </a:solidFill>
+                <a:latin typeface="BIZ UDPゴシック"/>
+                <a:ea typeface="BIZ UDPゴシック"/>
+                <a:cs typeface="BIZ UDPゴシック"/>
               </a:rPr>
               <a:t>不確かさをそのまま見せる</a:t>
             </a:r>
@@ -16799,6 +17546,9 @@
                 <a:solidFill>
                   <a:srgbClr val="0B3C6E"/>
                 </a:solidFill>
+                <a:latin typeface="BIZ UDPゴシック"/>
+                <a:ea typeface="BIZ UDPゴシック"/>
+                <a:cs typeface="BIZ UDPゴシック"/>
               </a:rPr>
               <a:t>② ゆらぎアバター</a:t>
             </a:r>
@@ -16882,6 +17632,9 @@
                 <a:solidFill>
                   <a:srgbClr val="0B3C6E"/>
                 </a:solidFill>
+                <a:latin typeface="BIZ UDPゴシック"/>
+                <a:ea typeface="BIZ UDPゴシック"/>
+                <a:cs typeface="BIZ UDPゴシック"/>
               </a:rPr>
               <a:t>性格や生活で個人差が大きい</a:t>
             </a:r>
@@ -16898,6 +17651,9 @@
                 <a:solidFill>
                   <a:srgbClr val="5A6676"/>
                 </a:solidFill>
+                <a:latin typeface="BIZ UDPゴシック"/>
+                <a:ea typeface="BIZ UDPゴシック"/>
+                <a:cs typeface="BIZ UDPゴシック"/>
               </a:rPr>
               <a:t>予備調査の平均的なモデルのままでは本人に当たらない</a:t>
             </a:r>
@@ -17097,6 +17853,9 @@
                 <a:solidFill>
                   <a:srgbClr val="12A38A"/>
                 </a:solidFill>
+                <a:latin typeface="BIZ UDPゴシック"/>
+                <a:ea typeface="BIZ UDPゴシック"/>
+                <a:cs typeface="BIZ UDPゴシック"/>
               </a:rPr>
               <a:t>記録で個人ごとに更新する</a:t>
             </a:r>
@@ -17113,6 +17872,9 @@
                 <a:solidFill>
                   <a:srgbClr val="0B3C6E"/>
                 </a:solidFill>
+                <a:latin typeface="BIZ UDPゴシック"/>
+                <a:ea typeface="BIZ UDPゴシック"/>
+                <a:cs typeface="BIZ UDPゴシック"/>
               </a:rPr>
               <a:t>① ベイズ個人ツイン</a:t>
             </a:r>
@@ -17196,6 +17958,9 @@
                 <a:solidFill>
                   <a:srgbClr val="0B3C6E"/>
                 </a:solidFill>
+                <a:latin typeface="BIZ UDPゴシック"/>
+                <a:ea typeface="BIZ UDPゴシック"/>
+                <a:cs typeface="BIZ UDPゴシック"/>
               </a:rPr>
               <a:t>8割が「推しが生きがい」</a:t>
             </a:r>
@@ -17212,6 +17977,9 @@
                 <a:solidFill>
                   <a:srgbClr val="5A6676"/>
                 </a:solidFill>
+                <a:latin typeface="BIZ UDPゴシック"/>
+                <a:ea typeface="BIZ UDPゴシック"/>
+                <a:cs typeface="BIZ UDPゴシック"/>
               </a:rPr>
               <a:t>「増やしたい」人が「減らしたい」人より多い</a:t>
             </a:r>
@@ -17411,6 +18179,9 @@
                 <a:solidFill>
                   <a:srgbClr val="12A38A"/>
                 </a:solidFill>
+                <a:latin typeface="BIZ UDPゴシック"/>
+                <a:ea typeface="BIZ UDPゴシック"/>
+                <a:cs typeface="BIZ UDPゴシック"/>
               </a:rPr>
               <a:t>減らさずに組み替える</a:t>
             </a:r>
@@ -17427,6 +18198,9 @@
                 <a:solidFill>
                   <a:srgbClr val="0B3C6E"/>
                 </a:solidFill>
+                <a:latin typeface="BIZ UDPゴシック"/>
+                <a:ea typeface="BIZ UDPゴシック"/>
+                <a:cs typeface="BIZ UDPゴシック"/>
               </a:rPr>
               <a:t>③ リバランス提案</a:t>
             </a:r>
@@ -17479,6 +18253,9 @@
                 <a:solidFill>
                   <a:srgbClr val="24303F"/>
                 </a:solidFill>
+                <a:latin typeface="BIZ UDPゴシック"/>
+                <a:ea typeface="BIZ UDPゴシック"/>
+                <a:cs typeface="BIZ UDPゴシック"/>
               </a:rPr>
               <a:t>OshiFit v2 のシステム構成（提案）</a:t>
             </a:r>
@@ -17497,9 +18274,14 @@
         </p:nvSpPr>
         <p:spPr/>
         <p:txBody>
-          <a:bodyPr/>
-          <a:p>
-            <a:r>
+          <a:bodyPr lIns="27432" rIns="0" wrap="none"/>
+          <a:p>
+            <a:r>
+              <a:rPr sz="900">
+                <a:latin typeface="BIZ UDPゴシック"/>
+                <a:ea typeface="BIZ UDPゴシック"/>
+                <a:cs typeface="BIZ UDPゴシック"/>
+              </a:rPr>
               <a:t>2026/10/16</a:t>
             </a:r>
           </a:p>
@@ -17520,7 +18302,11 @@
           <a:bodyPr/>
           <a:p>
             <a:fld id="{B6F15528-21DE-4FAA-801E-634DDDAF4B2B}" type="slidenum">
-              <a:rPr lang="en-US"/>
+              <a:rPr lang="en-US">
+                <a:latin typeface="BIZ UDPゴシック"/>
+                <a:ea typeface="BIZ UDPゴシック"/>
+                <a:cs typeface="BIZ UDPゴシック"/>
+              </a:rPr>
               <a:t>7</a:t>
             </a:fld>
           </a:p>
@@ -17677,6 +18463,9 @@
                 <a:solidFill>
                   <a:srgbClr val="0B3C6E"/>
                 </a:solidFill>
+                <a:latin typeface="BIZ UDPゴシック"/>
+                <a:ea typeface="BIZ UDPゴシック"/>
+                <a:cs typeface="BIZ UDPゴシック"/>
               </a:rPr>
               <a:t>TIPI-J</a:t>
             </a:r>
@@ -17693,6 +18482,9 @@
                 <a:solidFill>
                   <a:srgbClr val="5A6676"/>
                 </a:solidFill>
+                <a:latin typeface="BIZ UDPゴシック"/>
+                <a:ea typeface="BIZ UDPゴシック"/>
+                <a:cs typeface="BIZ UDPゴシック"/>
               </a:rPr>
               <a:t>初回・約1分</a:t>
             </a:r>
@@ -17850,6 +18642,9 @@
                 <a:solidFill>
                   <a:srgbClr val="0B3C6E"/>
                 </a:solidFill>
+                <a:latin typeface="BIZ UDPゴシック"/>
+                <a:ea typeface="BIZ UDPゴシック"/>
+                <a:cs typeface="BIZ UDPゴシック"/>
               </a:rPr>
               <a:t>毎日の記録</a:t>
             </a:r>
@@ -17866,6 +18661,9 @@
                 <a:solidFill>
                   <a:srgbClr val="5A6676"/>
                 </a:solidFill>
+                <a:latin typeface="BIZ UDPゴシック"/>
+                <a:ea typeface="BIZ UDPゴシック"/>
+                <a:cs typeface="BIZ UDPゴシック"/>
               </a:rPr>
               <a:t>1日約30秒</a:t>
             </a:r>
@@ -18023,6 +18821,9 @@
                 <a:solidFill>
                   <a:srgbClr val="0B3C6E"/>
                 </a:solidFill>
+                <a:latin typeface="BIZ UDPゴシック"/>
+                <a:ea typeface="BIZ UDPゴシック"/>
+                <a:cs typeface="BIZ UDPゴシック"/>
               </a:rPr>
               <a:t>本人の希望</a:t>
             </a:r>
@@ -18039,6 +18840,9 @@
                 <a:solidFill>
                   <a:srgbClr val="5A6676"/>
                 </a:solidFill>
+                <a:latin typeface="BIZ UDPゴシック"/>
+                <a:ea typeface="BIZ UDPゴシック"/>
+                <a:cs typeface="BIZ UDPゴシック"/>
               </a:rPr>
               <a:t>増やしたい／減らしたい</a:t>
             </a:r>
@@ -18128,6 +18932,9 @@
                 <a:solidFill>
                   <a:srgbClr val="FFFFFF"/>
                 </a:solidFill>
+                <a:latin typeface="BIZ UDPゴシック"/>
+                <a:ea typeface="BIZ UDPゴシック"/>
+                <a:cs typeface="BIZ UDPゴシック"/>
               </a:rPr>
               <a:t>①</a:t>
             </a:r>
@@ -18167,6 +18974,9 @@
                 <a:solidFill>
                   <a:srgbClr val="FFFFFF"/>
                 </a:solidFill>
+                <a:latin typeface="BIZ UDPゴシック"/>
+                <a:ea typeface="BIZ UDPゴシック"/>
+                <a:cs typeface="BIZ UDPゴシック"/>
               </a:rPr>
               <a:t>ベイズ個人ツイン</a:t>
             </a:r>
@@ -18206,6 +19016,9 @@
                 <a:solidFill>
                   <a:srgbClr val="FFFFFF"/>
                 </a:solidFill>
+                <a:latin typeface="BIZ UDPゴシック"/>
+                <a:ea typeface="BIZ UDPゴシック"/>
+                <a:cs typeface="BIZ UDPゴシック"/>
               </a:rPr>
               <a:t>記録で毎晩更新する</a:t>
             </a:r>
@@ -18222,6 +19035,9 @@
                 <a:solidFill>
                   <a:srgbClr val="FFFFFF"/>
                 </a:solidFill>
+                <a:latin typeface="BIZ UDPゴシック"/>
+                <a:ea typeface="BIZ UDPゴシック"/>
+                <a:cs typeface="BIZ UDPゴシック"/>
               </a:rPr>
               <a:t>自分専用の予測</a:t>
             </a:r>
@@ -18311,6 +19127,9 @@
                 <a:solidFill>
                   <a:srgbClr val="FFFFFF"/>
                 </a:solidFill>
+                <a:latin typeface="BIZ UDPゴシック"/>
+                <a:ea typeface="BIZ UDPゴシック"/>
+                <a:cs typeface="BIZ UDPゴシック"/>
               </a:rPr>
               <a:t>②</a:t>
             </a:r>
@@ -18350,6 +19169,9 @@
                 <a:solidFill>
                   <a:srgbClr val="FFFFFF"/>
                 </a:solidFill>
+                <a:latin typeface="BIZ UDPゴシック"/>
+                <a:ea typeface="BIZ UDPゴシック"/>
+                <a:cs typeface="BIZ UDPゴシック"/>
               </a:rPr>
               <a:t>リバランス提案</a:t>
             </a:r>
@@ -18389,6 +19211,9 @@
                 <a:solidFill>
                   <a:srgbClr val="FFFFFF"/>
                 </a:solidFill>
+                <a:latin typeface="BIZ UDPゴシック"/>
+                <a:ea typeface="BIZ UDPゴシック"/>
+                <a:cs typeface="BIZ UDPゴシック"/>
               </a:rPr>
               <a:t>減らさず組み替える</a:t>
             </a:r>
@@ -18405,6 +19230,9 @@
                 <a:solidFill>
                   <a:srgbClr val="FFFFFF"/>
                 </a:solidFill>
+                <a:latin typeface="BIZ UDPゴシック"/>
+                <a:ea typeface="BIZ UDPゴシック"/>
+                <a:cs typeface="BIZ UDPゴシック"/>
               </a:rPr>
               <a:t>3案（パレート最適）</a:t>
             </a:r>
@@ -18616,6 +19444,9 @@
                 <a:solidFill>
                   <a:srgbClr val="12A38A"/>
                 </a:solidFill>
+                <a:latin typeface="BIZ UDPゴシック"/>
+                <a:ea typeface="BIZ UDPゴシック"/>
+                <a:cs typeface="BIZ UDPゴシック"/>
               </a:rPr>
               <a:t>③④ みらいミラー</a:t>
             </a:r>
@@ -18703,6 +19534,9 @@
                 <a:solidFill>
                   <a:srgbClr val="E07A10"/>
                 </a:solidFill>
+                <a:latin typeface="BIZ UDPゴシック"/>
+                <a:ea typeface="BIZ UDPゴシック"/>
+                <a:cs typeface="BIZ UDPゴシック"/>
               </a:rPr>
               <a:t>今のまま</a:t>
             </a:r>
@@ -18742,6 +19576,9 @@
                 <a:solidFill>
                   <a:srgbClr val="12A38A"/>
                 </a:solidFill>
+                <a:latin typeface="BIZ UDPゴシック"/>
+                <a:ea typeface="BIZ UDPゴシック"/>
+                <a:cs typeface="BIZ UDPゴシック"/>
               </a:rPr>
               <a:t>提案どおり</a:t>
             </a:r>
@@ -18781,6 +19618,9 @@
                 <a:solidFill>
                   <a:srgbClr val="0B3C6E"/>
                 </a:solidFill>
+                <a:latin typeface="BIZ UDPゴシック"/>
+                <a:ea typeface="BIZ UDPゴシック"/>
+                <a:cs typeface="BIZ UDPゴシック"/>
               </a:rPr>
               <a:t>ゆらぎアバター</a:t>
             </a:r>
@@ -18797,6 +19637,9 @@
                 <a:solidFill>
                   <a:srgbClr val="24303F"/>
                 </a:solidFill>
+                <a:latin typeface="BIZ UDPゴシック"/>
+                <a:ea typeface="BIZ UDPゴシック"/>
+                <a:cs typeface="BIZ UDPゴシック"/>
               </a:rPr>
               <a:t>予測の幅を重なりで表示</a:t>
             </a:r>
@@ -18813,6 +19656,9 @@
                 <a:solidFill>
                   <a:srgbClr val="0B3C6E"/>
                 </a:solidFill>
+                <a:latin typeface="BIZ UDPゴシック"/>
+                <a:ea typeface="BIZ UDPゴシック"/>
+                <a:cs typeface="BIZ UDPゴシック"/>
               </a:rPr>
               <a:t>疲れの中身キュー</a:t>
             </a:r>
@@ -18829,6 +19675,9 @@
                 <a:solidFill>
                   <a:srgbClr val="24303F"/>
                 </a:solidFill>
+                <a:latin typeface="BIZ UDPゴシック"/>
+                <a:ea typeface="BIZ UDPゴシック"/>
+                <a:cs typeface="BIZ UDPゴシック"/>
               </a:rPr>
               <a:t>睡眠・出費・義務感・比較</a:t>
             </a:r>
@@ -18890,6 +19739,9 @@
                 <a:solidFill>
                   <a:srgbClr val="0B3C6E"/>
                 </a:solidFill>
+                <a:latin typeface="BIZ UDPゴシック"/>
+                <a:ea typeface="BIZ UDPゴシック"/>
+                <a:cs typeface="BIZ UDPゴシック"/>
               </a:rPr>
               <a:t>選ぶ → 1週間ためす → 実行チェック → 記録 → 毎晩更新 → 答え合わせ</a:t>
             </a:r>
@@ -19007,12 +19859,12 @@
           </a:fontRef>
         </p:style>
         <p:txBody>
-          <a:bodyPr rtlCol="0" anchor="ctr" wrap="square" lIns="45720" tIns="27432" rIns="45720" bIns="27432">
+          <a:bodyPr rtlCol="0" anchor="ctr" wrap="square" lIns="566928" tIns="27432" bIns="27432">
             <a:noAutofit/>
           </a:bodyPr>
           <a:lstStyle/>
           <a:p>
-            <a:pPr algn="ctr" marL="0" indent="0">
+            <a:pPr algn="l" marL="0" indent="0">
               <a:spcAft>
                 <a:spcPts val="400"/>
               </a:spcAft>
@@ -19023,6 +19875,9 @@
                 <a:solidFill>
                   <a:srgbClr val="E8457C"/>
                 </a:solidFill>
+                <a:latin typeface="BIZ UDPゴシック"/>
+                <a:ea typeface="BIZ UDPゴシック"/>
+                <a:cs typeface="BIZ UDPゴシック"/>
               </a:rPr>
               <a:t>セーフティ層：強いつらさの記録（WHO-5 素点13点未満など）では予測表示を止め、相談先を表示する</a:t>
             </a:r>
@@ -19141,6 +19996,9 @@
                 <a:solidFill>
                   <a:srgbClr val="24303F"/>
                 </a:solidFill>
+                <a:latin typeface="BIZ UDPゴシック"/>
+                <a:ea typeface="BIZ UDPゴシック"/>
+                <a:cs typeface="BIZ UDPゴシック"/>
               </a:rPr>
               <a:t>新しい仕組み① ベイズ個人ツイン</a:t>
             </a:r>
@@ -19159,9 +20017,14 @@
         </p:nvSpPr>
         <p:spPr/>
         <p:txBody>
-          <a:bodyPr/>
-          <a:p>
-            <a:r>
+          <a:bodyPr lIns="27432" rIns="0" wrap="none"/>
+          <a:p>
+            <a:r>
+              <a:rPr sz="900">
+                <a:latin typeface="BIZ UDPゴシック"/>
+                <a:ea typeface="BIZ UDPゴシック"/>
+                <a:cs typeface="BIZ UDPゴシック"/>
+              </a:rPr>
               <a:t>2026/10/16</a:t>
             </a:r>
           </a:p>
@@ -19182,7 +20045,11 @@
           <a:bodyPr/>
           <a:p>
             <a:fld id="{B6F15528-21DE-4FAA-801E-634DDDAF4B2B}" type="slidenum">
-              <a:rPr lang="en-US"/>
+              <a:rPr lang="en-US">
+                <a:latin typeface="BIZ UDPゴシック"/>
+                <a:ea typeface="BIZ UDPゴシック"/>
+                <a:cs typeface="BIZ UDPゴシック"/>
+              </a:rPr>
               <a:t>8</a:t>
             </a:fld>
           </a:p>
@@ -19217,7 +20084,7 @@
               <a:buClr>
                 <a:srgbClr val="0099FF"/>
               </a:buClr>
-              <a:buFont typeface="Arial"/>
+              <a:buFont typeface="BIZ UDPゴシック"/>
               <a:buChar char="•"/>
             </a:pPr>
             <a:r>
@@ -19225,6 +20092,9 @@
                 <a:solidFill>
                   <a:srgbClr val="24303F"/>
                 </a:solidFill>
+                <a:latin typeface="BIZ UDPゴシック"/>
+                <a:ea typeface="BIZ UDPゴシック"/>
+                <a:cs typeface="BIZ UDPゴシック"/>
               </a:rPr>
               <a:t>予備調査215名の係数を「事前分布」として使う</a:t>
             </a:r>
@@ -19237,7 +20107,7 @@
               <a:buClr>
                 <a:srgbClr val="0099FF"/>
               </a:buClr>
-              <a:buFont typeface="Arial"/>
+              <a:buFont typeface="BIZ UDPゴシック"/>
               <a:buChar char="•"/>
             </a:pPr>
             <a:r>
@@ -19245,6 +20115,9 @@
                 <a:solidFill>
                   <a:srgbClr val="24303F"/>
                 </a:solidFill>
+                <a:latin typeface="BIZ UDPゴシック"/>
+                <a:ea typeface="BIZ UDPゴシック"/>
+                <a:cs typeface="BIZ UDPゴシック"/>
               </a:rPr>
               <a:t>毎日の記録で、その人専用の係数（個人差）を毎晩更新する</a:t>
             </a:r>
@@ -19257,7 +20130,7 @@
               <a:buClr>
                 <a:srgbClr val="0099FF"/>
               </a:buClr>
-              <a:buFont typeface="Arial"/>
+              <a:buFont typeface="BIZ UDPゴシック"/>
               <a:buChar char="•"/>
             </a:pPr>
             <a:r>
@@ -19265,6 +20138,9 @@
                 <a:solidFill>
                   <a:srgbClr val="24303F"/>
                 </a:solidFill>
+                <a:latin typeface="BIZ UDPゴシック"/>
+                <a:ea typeface="BIZ UDPゴシック"/>
+                <a:cs typeface="BIZ UDPゴシック"/>
               </a:rPr>
               <a:t>予測は1つの値ではなく分布 → 予測区間が自然に出る</a:t>
             </a:r>
@@ -19277,7 +20153,7 @@
               <a:buClr>
                 <a:srgbClr val="E8457C"/>
               </a:buClr>
-              <a:buFont typeface="Arial"/>
+              <a:buFont typeface="BIZ UDPゴシック"/>
               <a:buChar char="•"/>
             </a:pPr>
             <a:r>
@@ -19285,6 +20161,9 @@
                 <a:solidFill>
                   <a:srgbClr val="24303F"/>
                 </a:solidFill>
+                <a:latin typeface="BIZ UDPゴシック"/>
+                <a:ea typeface="BIZ UDPゴシック"/>
+                <a:cs typeface="BIZ UDPゴシック"/>
               </a:rPr>
               <a:t>計画書の「2週間の記録で個人補正（混合モデル）」を、毎日少しずつ進む形にしたもの</a:t>
             </a:r>
@@ -19368,8 +20247,11 @@
                 <a:solidFill>
                   <a:srgbClr val="FFFFFF"/>
                 </a:solidFill>
-              </a:rPr>
-              <a:t>予測 = (全体の傾向 β + 個人差 bᵢ) × 行動</a:t>
+                <a:latin typeface="BIZ UDPゴシック"/>
+                <a:ea typeface="BIZ UDPゴシック"/>
+                <a:cs typeface="BIZ UDPゴシック"/>
+              </a:rPr>
+              <a:t>予測 = (全体の傾向 + 個人差) × 行動</a:t>
             </a:r>
           </a:p>
           <a:p>
@@ -19384,8 +20266,11 @@
                 <a:solidFill>
                   <a:srgbClr val="CCE9FF"/>
                 </a:solidFill>
-              </a:rPr>
-              <a:t>bᵢ ～ N(0, τ²)：最初は全体の傾向、記録が増えるほど本人寄りに</a:t>
+                <a:latin typeface="BIZ UDPゴシック"/>
+                <a:ea typeface="BIZ UDPゴシック"/>
+                <a:cs typeface="BIZ UDPゴシック"/>
+              </a:rPr>
+              <a:t>個人差は平均0の正規分布から。記録が増えるほど本人寄りに</a:t>
             </a:r>
           </a:p>
         </p:txBody>
@@ -19467,6 +20352,9 @@
                 <a:solidFill>
                   <a:srgbClr val="5A6676"/>
                 </a:solidFill>
+                <a:latin typeface="BIZ UDPゴシック"/>
+                <a:ea typeface="BIZ UDPゴシック"/>
+                <a:cs typeface="BIZ UDPゴシック"/>
               </a:rPr>
               <a:t>端末内で計算できる軽さ（正規分布の更新式のみ）。サーバーには記録の数値だけを送る</a:t>
             </a:r>
@@ -19524,6 +20412,9 @@
                 <a:solidFill>
                   <a:srgbClr val="0B3C6E"/>
                 </a:solidFill>
+                <a:latin typeface="BIZ UDPゴシック"/>
+                <a:ea typeface="BIZ UDPゴシック"/>
+                <a:cs typeface="BIZ UDPゴシック"/>
               </a:rPr>
               <a:t>14日の記録で幅が約30%縮む（試算）</a:t>
             </a:r>
@@ -19540,6 +20431,9 @@
                 <a:solidFill>
                   <a:srgbClr val="5A6676"/>
                 </a:solidFill>
+                <a:latin typeface="BIZ UDPゴシック"/>
+                <a:ea typeface="BIZ UDPゴシック"/>
+                <a:cs typeface="BIZ UDPゴシック"/>
               </a:rPr>
               <a:t>合成データによるシミュレーション。残る幅は週ごとの自然な揺れ</a:t>
             </a:r>
@@ -19592,6 +20486,9 @@
                 <a:solidFill>
                   <a:srgbClr val="24303F"/>
                 </a:solidFill>
+                <a:latin typeface="BIZ UDPゴシック"/>
+                <a:ea typeface="BIZ UDPゴシック"/>
+                <a:cs typeface="BIZ UDPゴシック"/>
               </a:rPr>
               <a:t>新しい仕組み② ゆらぎアバター</a:t>
             </a:r>
@@ -19610,9 +20507,14 @@
         </p:nvSpPr>
         <p:spPr/>
         <p:txBody>
-          <a:bodyPr/>
-          <a:p>
-            <a:r>
+          <a:bodyPr lIns="27432" rIns="0" wrap="none"/>
+          <a:p>
+            <a:r>
+              <a:rPr sz="900">
+                <a:latin typeface="BIZ UDPゴシック"/>
+                <a:ea typeface="BIZ UDPゴシック"/>
+                <a:cs typeface="BIZ UDPゴシック"/>
+              </a:rPr>
               <a:t>2026/10/16</a:t>
             </a:r>
           </a:p>
@@ -19633,7 +20535,11 @@
           <a:bodyPr/>
           <a:p>
             <a:fld id="{B6F15528-21DE-4FAA-801E-634DDDAF4B2B}" type="slidenum">
-              <a:rPr lang="en-US"/>
+              <a:rPr lang="en-US">
+                <a:latin typeface="BIZ UDPゴシック"/>
+                <a:ea typeface="BIZ UDPゴシック"/>
+                <a:cs typeface="BIZ UDPゴシック"/>
+              </a:rPr>
               <a:t>9</a:t>
             </a:fld>
           </a:p>
@@ -19740,6 +20646,9 @@
                 <a:solidFill>
                   <a:srgbClr val="0B3C6E"/>
                 </a:solidFill>
+                <a:latin typeface="BIZ UDPゴシック"/>
+                <a:ea typeface="BIZ UDPゴシック"/>
+                <a:cs typeface="BIZ UDPゴシック"/>
               </a:rPr>
               <a:t>記録0日</a:t>
             </a:r>
@@ -19779,6 +20688,9 @@
                 <a:solidFill>
                   <a:srgbClr val="5A6676"/>
                 </a:solidFill>
+                <a:latin typeface="BIZ UDPゴシック"/>
+                <a:ea typeface="BIZ UDPゴシック"/>
+                <a:cs typeface="BIZ UDPゴシック"/>
               </a:rPr>
               <a:t>未来はまだぼやけている</a:t>
             </a:r>
@@ -19928,6 +20840,9 @@
                 <a:solidFill>
                   <a:srgbClr val="0B3C6E"/>
                 </a:solidFill>
+                <a:latin typeface="BIZ UDPゴシック"/>
+                <a:ea typeface="BIZ UDPゴシック"/>
+                <a:cs typeface="BIZ UDPゴシック"/>
               </a:rPr>
               <a:t>記録7日</a:t>
             </a:r>
@@ -19967,6 +20882,9 @@
                 <a:solidFill>
                   <a:srgbClr val="5A6676"/>
                 </a:solidFill>
+                <a:latin typeface="BIZ UDPゴシック"/>
+                <a:ea typeface="BIZ UDPゴシック"/>
+                <a:cs typeface="BIZ UDPゴシック"/>
               </a:rPr>
               <a:t>少しずつ重なってくる</a:t>
             </a:r>
@@ -20116,6 +21034,9 @@
                 <a:solidFill>
                   <a:srgbClr val="12A38A"/>
                 </a:solidFill>
+                <a:latin typeface="BIZ UDPゴシック"/>
+                <a:ea typeface="BIZ UDPゴシック"/>
+                <a:cs typeface="BIZ UDPゴシック"/>
               </a:rPr>
               <a:t>記録14日</a:t>
             </a:r>
@@ -20155,6 +21076,9 @@
                 <a:solidFill>
                   <a:srgbClr val="5A6676"/>
                 </a:solidFill>
+                <a:latin typeface="BIZ UDPゴシック"/>
+                <a:ea typeface="BIZ UDPゴシック"/>
+                <a:cs typeface="BIZ UDPゴシック"/>
               </a:rPr>
               <a:t>未来の自分がくっきり</a:t>
             </a:r>
@@ -20312,6 +21236,9 @@
                 <a:solidFill>
                   <a:srgbClr val="0B3C6E"/>
                 </a:solidFill>
+                <a:latin typeface="BIZ UDPゴシック"/>
+                <a:ea typeface="BIZ UDPゴシック"/>
+                <a:cs typeface="BIZ UDPゴシック"/>
               </a:rPr>
               <a:t>しくみ</a:t>
             </a:r>
@@ -20351,6 +21278,9 @@
                 <a:solidFill>
                   <a:srgbClr val="24303F"/>
                 </a:solidFill>
+                <a:latin typeface="BIZ UDPゴシック"/>
+                <a:ea typeface="BIZ UDPゴシック"/>
+                <a:cs typeface="BIZ UDPゴシック"/>
               </a:rPr>
               <a:t>予測の分布から20通りの未来を引き、表情を3区分にして重ねて描く。濃さ＝その未来の起こりやすさ</a:t>
             </a:r>
@@ -20508,6 +21438,9 @@
                 <a:solidFill>
                   <a:srgbClr val="0B3C6E"/>
                 </a:solidFill>
+                <a:latin typeface="BIZ UDPゴシック"/>
+                <a:ea typeface="BIZ UDPゴシック"/>
+                <a:cs typeface="BIZ UDPゴシック"/>
               </a:rPr>
               <a:t>ねらい</a:t>
             </a:r>
@@ -20547,6 +21480,9 @@
                 <a:solidFill>
                   <a:srgbClr val="24303F"/>
                 </a:solidFill>
+                <a:latin typeface="BIZ UDPゴシック"/>
+                <a:ea typeface="BIZ UDPゴシック"/>
+                <a:cs typeface="BIZ UDPゴシック"/>
               </a:rPr>
               <a:t>不確かさを正直に見せる。「未来の解像度」を上げたくて記録を続けたくなる</a:t>
             </a:r>
@@ -20704,6 +21640,9 @@
                 <a:solidFill>
                   <a:srgbClr val="0B3C6E"/>
                 </a:solidFill>
+                <a:latin typeface="BIZ UDPゴシック"/>
+                <a:ea typeface="BIZ UDPゴシック"/>
+                <a:cs typeface="BIZ UDPゴシック"/>
               </a:rPr>
               <a:t>根拠</a:t>
             </a:r>
@@ -20743,6 +21682,9 @@
                 <a:solidFill>
                   <a:srgbClr val="24303F"/>
                 </a:solidFill>
+                <a:latin typeface="BIZ UDPゴシック"/>
+                <a:ea typeface="BIZ UDPゴシック"/>
+                <a:cs typeface="BIZ UDPゴシック"/>
               </a:rPr>
               <a:t>仮想的な結果の提示（Hullman et al., 2015）、頻度での表現（Kay et al., 2016）、プロテウス効果</a:t>
             </a:r>
@@ -20800,12 +21742,12 @@
     </a:clrScheme>
     <a:fontScheme name="mixlab">
       <a:majorFont>
-        <a:latin typeface="Arial"/>
+        <a:latin typeface="BIZ UDPゴシック"/>
         <a:ea typeface="BIZ UDPゴシック"/>
         <a:cs typeface=""/>
       </a:majorFont>
       <a:minorFont>
-        <a:latin typeface="Arial"/>
+        <a:latin typeface="BIZ UDPゴシック"/>
         <a:ea typeface="BIZ UDPゴシック"/>
         <a:cs typeface=""/>
       </a:minorFont>
@@ -21001,7 +21943,7 @@
     </a:clrScheme>
     <a:fontScheme name="Office">
       <a:majorFont>
-        <a:latin typeface="游ゴシック Light" panose="020F0302020204030204"/>
+        <a:latin typeface="BIZ UDPゴシック"/>
         <a:ea typeface=""/>
         <a:cs typeface=""/>
         <a:font script="Jpan" typeface="游ゴシック Light"/>
@@ -21036,7 +21978,7 @@
         <a:font script="Geor" typeface="Sylfaen"/>
       </a:majorFont>
       <a:minorFont>
-        <a:latin typeface="游ゴシック" panose="020F0502020204030204"/>
+        <a:latin typeface="BIZ UDPゴシック"/>
         <a:ea typeface=""/>
         <a:cs typeface=""/>
         <a:font script="Jpan" typeface="游ゴシック"/>

</xml_diff>